<commit_message>
docs(docs): align presentation format strictly with lab evaluation rubric
- Structure slides across the 5 required curriculum sections
- Feature group members block on title slide with Rayyan Mustafa (2312335)
- Include detailed concept mappings for Labs 01-05 and benchmark results
</commit_message>
<xml_diff>
--- a/CaterIQ_Presentation_Rayyan_Mustafa_2312335.pptx
+++ b/CaterIQ_Presentation_Rayyan_Mustafa_2312335.pptx
@@ -3146,8 +3146,8 @@
         </p:nvSpPr>
         <p:spPr>
           <a:xfrm>
-            <a:off x="731520" y="1097280"/>
-            <a:ext cx="10728655" cy="4663440"/>
+            <a:off x="731520" y="822960"/>
+            <a:ext cx="10728655" cy="5212080"/>
           </a:xfrm>
           <a:prstGeom prst="roundRect">
             <a:avLst/>
@@ -3191,8 +3191,8 @@
         </p:nvSpPr>
         <p:spPr>
           <a:xfrm>
-            <a:off x="1188720" y="1463040"/>
-            <a:ext cx="3840480" cy="365760"/>
+            <a:off x="1188720" y="1188720"/>
+            <a:ext cx="4206240" cy="365760"/>
           </a:xfrm>
           <a:prstGeom prst="roundRect">
             <a:avLst/>
@@ -3232,7 +3232,7 @@
               </a:defRPr>
             </a:pPr>
             <a:r>
-              <a:t>  ARTIFICIAL INTELLIGENCE LAB — SEMESTER PROJECT  </a:t>
+              <a:t> ARTIFICIAL INTELLIGENCE LAB (SEMESTER PROJECT) </a:t>
             </a:r>
           </a:p>
         </p:txBody>
@@ -3245,7 +3245,7 @@
         </p:nvSpPr>
         <p:spPr>
           <a:xfrm>
-            <a:off x="1188720" y="2011680"/>
+            <a:off x="1188720" y="1737360"/>
             <a:ext cx="9784080" cy="1371600"/>
           </a:xfrm>
           <a:prstGeom prst="rect">
@@ -3273,30 +3273,75 @@
           <a:p>
             <a:pPr>
               <a:spcBef>
-                <a:spcPts val="1000"/>
+                <a:spcPts val="800"/>
               </a:spcBef>
-              <a:defRPr sz="1800">
+              <a:defRPr sz="1700">
                 <a:solidFill>
                   <a:srgbClr val="38BDF8"/>
                 </a:solidFill>
               </a:defRPr>
             </a:pPr>
             <a:r>
-              <a:t>Uninformed State-Space Search (BFS &amp; DFS) for Real-World Catering Optimization</a:t>
-            </a:r>
-          </a:p>
-        </p:txBody>
-      </p:sp>
-      <p:sp>
-        <p:nvSpPr>
-          <p:cNvPr id="6" name="TextBox 5"/>
+              <a:t>Uninformed State-Space Search (BFS &amp; DFS) for Automated Catering Optimization</a:t>
+            </a:r>
+          </a:p>
+        </p:txBody>
+      </p:sp>
+      <p:sp>
+        <p:nvSpPr>
+          <p:cNvPr id="6" name="Rounded Rectangle 5"/>
+          <p:cNvSpPr/>
+          <p:nvPr/>
+        </p:nvSpPr>
+        <p:spPr>
+          <a:xfrm>
+            <a:off x="1188720" y="3383280"/>
+            <a:ext cx="9784080" cy="2194560"/>
+          </a:xfrm>
+          <a:prstGeom prst="roundRect">
+            <a:avLst/>
+          </a:prstGeom>
+          <a:solidFill>
+            <a:srgbClr val="0F172A"/>
+          </a:solidFill>
+          <a:ln w="12700">
+            <a:solidFill>
+              <a:srgbClr val="2D3752"/>
+            </a:solidFill>
+          </a:ln>
+        </p:spPr>
+        <p:style>
+          <a:lnRef idx="1">
+            <a:schemeClr val="accent1"/>
+          </a:lnRef>
+          <a:fillRef idx="3">
+            <a:schemeClr val="accent1"/>
+          </a:fillRef>
+          <a:effectRef idx="2">
+            <a:schemeClr val="accent1"/>
+          </a:effectRef>
+          <a:fontRef idx="minor">
+            <a:schemeClr val="lt1"/>
+          </a:fontRef>
+        </p:style>
+        <p:txBody>
+          <a:bodyPr rtlCol="0" anchor="ctr"/>
+          <a:lstStyle/>
+          <a:p>
+            <a:pPr algn="ctr"/>
+          </a:p>
+        </p:txBody>
+      </p:sp>
+      <p:sp>
+        <p:nvSpPr>
+          <p:cNvPr id="7" name="TextBox 6"/>
           <p:cNvSpPr txBox="1"/>
           <p:nvPr/>
         </p:nvSpPr>
         <p:spPr>
           <a:xfrm>
-            <a:off x="1188720" y="3931920"/>
-            <a:ext cx="9784080" cy="1463040"/>
+            <a:off x="1463040" y="3566160"/>
+            <a:ext cx="9235440" cy="1828800"/>
           </a:xfrm>
           <a:prstGeom prst="rect">
             <a:avLst/>
@@ -3310,44 +3355,44 @@
           <a:lstStyle/>
           <a:p>
             <a:pPr>
+              <a:defRPr sz="1200" b="1">
+                <a:solidFill>
+                  <a:srgbClr val="6366F1"/>
+                </a:solidFill>
+              </a:defRPr>
+            </a:pPr>
+            <a:r>
+              <a:t>PROJECT AUTHORS / GROUP MEMBERS:</a:t>
+            </a:r>
+          </a:p>
+          <a:p>
+            <a:pPr>
+              <a:spcBef>
+                <a:spcPts val="800"/>
+              </a:spcBef>
               <a:defRPr sz="1600" b="1">
                 <a:solidFill>
+                  <a:srgbClr val="EF4444"/>
+                </a:solidFill>
+              </a:defRPr>
+            </a:pPr>
+            <a:r>
+              <a:t>• Rayyan Mustafa  —  Roll / Reg No: 2312335 (Team Lead / Presenter)</a:t>
+            </a:r>
+          </a:p>
+          <a:p>
+            <a:pPr>
+              <a:spcBef>
+                <a:spcPts val="800"/>
+              </a:spcBef>
+              <a:defRPr sz="1200">
+                <a:solidFill>
                   <a:srgbClr val="F8FAFC"/>
                 </a:solidFill>
               </a:defRPr>
             </a:pPr>
             <a:r>
-              <a:t>Student: Rayyan Mustafa</a:t>
-            </a:r>
-          </a:p>
-          <a:p>
-            <a:pPr>
-              <a:spcBef>
-                <a:spcPts val="400"/>
-              </a:spcBef>
-              <a:defRPr sz="1400" b="1">
-                <a:solidFill>
-                  <a:srgbClr val="EF4444"/>
-                </a:solidFill>
-              </a:defRPr>
-            </a:pPr>
-            <a:r>
-              <a:t>Registration Number: 2312335</a:t>
-            </a:r>
-          </a:p>
-          <a:p>
-            <a:pPr>
-              <a:spcBef>
-                <a:spcPts val="600"/>
-              </a:spcBef>
-              <a:defRPr sz="1300">
-                <a:solidFill>
-                  <a:srgbClr val="94A3B8"/>
-                </a:solidFill>
-              </a:defRPr>
-            </a:pPr>
-            <a:r>
-              <a:t>Curriculum Scope: Labs 01–05 (OOP, BFS Allergen Safe-Paths, DFS Constraint Satisfaction)</a:t>
+              <a:t>Course: Artificial Intelligence Lab (6th Semester)   |   Focus: Labs 01–05 Curriculum</a:t>
             </a:r>
           </a:p>
           <a:p>
@@ -3362,7 +3407,7 @@
               </a:defRPr>
             </a:pPr>
             <a:r>
-              <a:t>Implementation: 100% Pure Python • In-Memory Knowledge Graphs • Interactive Streamlit UI</a:t>
+              <a:t>Technology Stack: 100% Pure Python  •  Russell &amp; Norvig Paradigm  •  Interactive Streamlit UI</a:t>
             </a:r>
           </a:p>
         </p:txBody>
@@ -3436,7 +3481,7 @@
         </p:nvSpPr>
         <p:spPr>
           <a:xfrm>
-            <a:off x="731520" y="411480"/>
+            <a:off x="731520" y="365760"/>
             <a:ext cx="10698480" cy="320040"/>
           </a:xfrm>
           <a:prstGeom prst="rect">
@@ -3458,7 +3503,7 @@
               </a:defRPr>
             </a:pPr>
             <a:r>
-              <a:t>ARTIFICIAL INTELLIGENCE LAB • SEMESTER PROJECT</a:t>
+              <a:t>SECTION 1: PROJECT IDEA &amp; BRIEF BACKGROUND</a:t>
             </a:r>
           </a:p>
         </p:txBody>
@@ -3471,7 +3516,7 @@
         </p:nvSpPr>
         <p:spPr>
           <a:xfrm>
-            <a:off x="731520" y="685800"/>
+            <a:off x="731520" y="658368"/>
             <a:ext cx="10698480" cy="640080"/>
           </a:xfrm>
           <a:prstGeom prst="rect">
@@ -3486,14 +3531,14 @@
           <a:lstStyle/>
           <a:p>
             <a:pPr>
-              <a:defRPr sz="2400" b="1">
+              <a:defRPr sz="2300" b="1">
                 <a:solidFill>
                   <a:srgbClr val="F8FAFC"/>
                 </a:solidFill>
               </a:defRPr>
             </a:pPr>
             <a:r>
-              <a:t>Project Overview &amp; Curriculum Alignment</a:t>
+              <a:t>1. Project Title &amp; Introduction</a:t>
             </a:r>
           </a:p>
         </p:txBody>
@@ -3551,7 +3596,7 @@
         </p:nvSpPr>
         <p:spPr>
           <a:xfrm>
-            <a:off x="1005840" y="1783080"/>
+            <a:off x="1005840" y="1755648"/>
             <a:ext cx="4572000" cy="411480"/>
           </a:xfrm>
           <a:prstGeom prst="rect">
@@ -3573,7 +3618,7 @@
               </a:defRPr>
             </a:pPr>
             <a:r>
-              <a:t>Real-World Problem Formulation</a:t>
+              <a:t>Project Idea &amp; Concept</a:t>
             </a:r>
           </a:p>
         </p:txBody>
@@ -3608,7 +3653,7 @@
               </a:defRPr>
             </a:pPr>
             <a:r>
-              <a:t>• Catering Industry Bottleneck: </a:t>
+              <a:t>• What is CaterIQ?: </a:t>
             </a:r>
             <a:r>
               <a:rPr b="0" sz="1200">
@@ -3616,7 +3661,7 @@
                   <a:srgbClr val="94A3B8"/>
                 </a:solidFill>
               </a:rPr>
-              <a:t>High-volume caterers struggle with complex guest allergies and tight budget constraints under strict deadlines.</a:t>
+              <a:t>An intelligent catering decision-support studio that automates recipe allergen adaptation and multi-course menu quotation packaging.</a:t>
             </a:r>
           </a:p>
           <a:p>
@@ -3631,7 +3676,7 @@
               </a:defRPr>
             </a:pPr>
             <a:r>
-              <a:t>• Manual Trial-and-Error Fails: </a:t>
+              <a:t>• Core AI Methodology: </a:t>
             </a:r>
             <a:r>
               <a:rPr b="0" sz="1200">
@@ -3639,7 +3684,7 @@
                   <a:srgbClr val="94A3B8"/>
                 </a:solidFill>
               </a:rPr>
-              <a:t>Cross-referencing recipes against celiac, nut, and dairy allergies while preserving dish composition is error-prone.</a:t>
+              <a:t>Replaces manual guessing with classical Uninformed State-Space Search (BFS &amp; DFS) to guarantee optimal solutions.</a:t>
             </a:r>
           </a:p>
           <a:p>
@@ -3654,7 +3699,7 @@
               </a:defRPr>
             </a:pPr>
             <a:r>
-              <a:t>• Uninformed Search Solution: </a:t>
+              <a:t>• 100% Pure Python Foundation: </a:t>
             </a:r>
             <a:r>
               <a:rPr b="0" sz="1200">
@@ -3662,7 +3707,7 @@
                   <a:srgbClr val="94A3B8"/>
                 </a:solidFill>
               </a:rPr>
-              <a:t>State-space graph traversal guarantees mathematically optimal ingredient substitutions and compliant 3-course menus.</a:t>
+              <a:t>Engineered completely in pure Python without bloated SQL databases or heavy web stacks. All state graphs reside in memory.</a:t>
             </a:r>
           </a:p>
           <a:p>
@@ -3677,7 +3722,7 @@
               </a:defRPr>
             </a:pPr>
             <a:r>
-              <a:t>• 100% Pure Python: </a:t>
+              <a:t>• Modern Interactive Interface: </a:t>
             </a:r>
             <a:r>
               <a:rPr b="0" sz="1200">
@@ -3685,7 +3730,7 @@
                   <a:srgbClr val="94A3B8"/>
                 </a:solidFill>
               </a:rPr>
-              <a:t>Zero external database overhead (SQLite/PostgreSQL avoided). Uses in-memory adjacency sets for instant execution.</a:t>
+              <a:t>Coupled with a Next.js-inspired high-contrast Streamlit dashboard for real-time demonstration and metric tracking.</a:t>
             </a:r>
           </a:p>
         </p:txBody>
@@ -3743,7 +3788,7 @@
         </p:nvSpPr>
         <p:spPr>
           <a:xfrm>
-            <a:off x="6583680" y="1783080"/>
+            <a:off x="6583680" y="1755648"/>
             <a:ext cx="4572000" cy="411480"/>
           </a:xfrm>
           <a:prstGeom prst="rect">
@@ -3765,7 +3810,7 @@
               </a:defRPr>
             </a:pPr>
             <a:r>
-              <a:t>Syllabus Mapping (Weeks 1–5)</a:t>
+              <a:t>Industry Background &amp; Motivation</a:t>
             </a:r>
           </a:p>
         </p:txBody>
@@ -3800,7 +3845,7 @@
               </a:defRPr>
             </a:pPr>
             <a:r>
-              <a:t>• Weeks 1 &amp; 2: OOP &amp; Data Modeling: </a:t>
+              <a:t>• High-Stakes Catering Environment: </a:t>
             </a:r>
             <a:r>
               <a:rPr b="0" sz="1200">
@@ -3808,7 +3853,7 @@
                   <a:srgbClr val="94A3B8"/>
                 </a:solidFill>
               </a:rPr>
-              <a:t>Russell &amp; Norvig abstract classes (Problem, Node, SearchResult). In-memory knowledge graph in data.py.</a:t>
+              <a:t>Large events (weddings, corporate summits) must accommodate severe guest dietary restrictions (peanut anaphylaxis, celiac disease).</a:t>
             </a:r>
           </a:p>
           <a:p>
@@ -3823,7 +3868,7 @@
               </a:defRPr>
             </a:pPr>
             <a:r>
-              <a:t>• Weeks 3 &amp; 4: Lab 04 — BFS Search: </a:t>
+              <a:t>• The 'Recipe Preservation' Dilemma: </a:t>
             </a:r>
             <a:r>
               <a:rPr b="0" sz="1200">
@@ -3831,7 +3876,7 @@
                   <a:srgbClr val="94A3B8"/>
                 </a:solidFill>
               </a:rPr>
-              <a:t>Breadth-First Search on ingredient substitution graph. Guarantees minimal number of recipe swaps.</a:t>
+              <a:t>Swapping ingredients carelessly ruins taste profiles or triggers secondary allergens. Chefs need the absolute minimum number of swaps.</a:t>
             </a:r>
           </a:p>
           <a:p>
@@ -3846,7 +3891,7 @@
               </a:defRPr>
             </a:pPr>
             <a:r>
-              <a:t>• Week 5: Lab 05 — DFS &amp; Backtracking: </a:t>
+              <a:t>• Budget &amp; Course Balancing: </a:t>
             </a:r>
             <a:r>
               <a:rPr b="0" sz="1200">
@@ -3854,7 +3899,7 @@
                   <a:srgbClr val="94A3B8"/>
                 </a:solidFill>
               </a:rPr>
-              <a:t>Depth-First Search for 3-course package construction with budget and dietary constraint satisfaction.</a:t>
+              <a:t>Clients impose strict per-head budgets while demanding balanced dietary quotas (e.g. at least 2 gluten-free, 1 vegetarian course).</a:t>
             </a:r>
           </a:p>
           <a:p>
@@ -3869,7 +3914,7 @@
               </a:defRPr>
             </a:pPr>
             <a:r>
-              <a:t>• Branch-and-Bound Pruning: </a:t>
+              <a:t>• Why Classical AI?: </a:t>
             </a:r>
             <a:r>
               <a:rPr b="0" sz="1200">
@@ -3877,7 +3922,7 @@
                   <a:srgbClr val="94A3B8"/>
                 </a:solidFill>
               </a:rPr>
-              <a:t>Early constraint checks discard invalid subtrees before expanding deeper, preventing exponential explosion.</a:t>
+              <a:t>Exact search algorithms ensure 100% mathematical guarantees for safety and budget adherence without hallucination risks.</a:t>
             </a:r>
           </a:p>
         </p:txBody>
@@ -3951,7 +3996,7 @@
         </p:nvSpPr>
         <p:spPr>
           <a:xfrm>
-            <a:off x="731520" y="411480"/>
+            <a:off x="731520" y="365760"/>
             <a:ext cx="10698480" cy="320040"/>
           </a:xfrm>
           <a:prstGeom prst="rect">
@@ -3973,7 +4018,7 @@
               </a:defRPr>
             </a:pPr>
             <a:r>
-              <a:t>ARTIFICIAL INTELLIGENCE LAB • SEMESTER PROJECT</a:t>
+              <a:t>SECTION 2: WHAT THE APPLICATION AIMS TO ACHIEVE</a:t>
             </a:r>
           </a:p>
         </p:txBody>
@@ -3986,7 +4031,7 @@
         </p:nvSpPr>
         <p:spPr>
           <a:xfrm>
-            <a:off x="731520" y="685800"/>
+            <a:off x="731520" y="658368"/>
             <a:ext cx="10698480" cy="640080"/>
           </a:xfrm>
           <a:prstGeom prst="rect">
@@ -4001,14 +4046,14 @@
           <a:lstStyle/>
           <a:p>
             <a:pPr>
-              <a:defRPr sz="2400" b="1">
+              <a:defRPr sz="2300" b="1">
                 <a:solidFill>
                   <a:srgbClr val="F8FAFC"/>
                 </a:solidFill>
               </a:defRPr>
             </a:pPr>
             <a:r>
-              <a:t>Theoretical Foundation: Russell &amp; Norvig AI Paradigm</a:t>
+              <a:t>2. Problem Statement &amp; Objectives</a:t>
             </a:r>
           </a:p>
         </p:txBody>
@@ -4022,7 +4067,7 @@
         <p:spPr>
           <a:xfrm>
             <a:off x="731520" y="1554480"/>
-            <a:ext cx="3337560" cy="4754880"/>
+            <a:ext cx="5120640" cy="4754880"/>
           </a:xfrm>
           <a:prstGeom prst="roundRect">
             <a:avLst/>
@@ -4066,8 +4111,8 @@
         </p:nvSpPr>
         <p:spPr>
           <a:xfrm>
-            <a:off x="1005840" y="1783080"/>
-            <a:ext cx="2788920" cy="411480"/>
+            <a:off x="1005840" y="1755648"/>
+            <a:ext cx="4572000" cy="411480"/>
           </a:xfrm>
           <a:prstGeom prst="rect">
             <a:avLst/>
@@ -4083,12 +4128,12 @@
             <a:pPr>
               <a:defRPr sz="1500" b="1">
                 <a:solidFill>
-                  <a:srgbClr val="38BDF8"/>
-                </a:solidFill>
-              </a:defRPr>
-            </a:pPr>
-            <a:r>
-              <a:t>1. Problem Abstraction</a:t>
+                  <a:srgbClr val="F59E0B"/>
+                </a:solidFill>
+              </a:defRPr>
+            </a:pPr>
+            <a:r>
+              <a:t>Problem Statement</a:t>
             </a:r>
           </a:p>
         </p:txBody>
@@ -4101,8 +4146,8 @@
         </p:nvSpPr>
         <p:spPr>
           <a:xfrm>
-            <a:off x="960120" y="2194560"/>
-            <a:ext cx="2880360" cy="3840480"/>
+            <a:off x="1005840" y="2194560"/>
+            <a:ext cx="4572000" cy="3840480"/>
           </a:xfrm>
           <a:prstGeom prst="rect">
             <a:avLst/>
@@ -4116,119 +4161,91 @@
           <a:lstStyle/>
           <a:p>
             <a:pPr>
-              <a:defRPr b="1" sz="1200">
-                <a:solidFill>
-                  <a:srgbClr val="38BDF8"/>
-                </a:solidFill>
-              </a:defRPr>
-            </a:pPr>
-            <a:r>
-              <a:t>initial_state()</a:t>
-            </a:r>
-            <a:br/>
-            <a:r>
-              <a:rPr b="0" sz="1100">
+              <a:defRPr b="1" sz="1300">
+                <a:solidFill>
+                  <a:srgbClr val="F8FAFC"/>
+                </a:solidFill>
+              </a:defRPr>
+            </a:pPr>
+            <a:r>
+              <a:t>• Manual Recipe Guesswork: </a:t>
+            </a:r>
+            <a:r>
+              <a:rPr b="0" sz="1200">
                 <a:solidFill>
                   <a:srgbClr val="94A3B8"/>
                 </a:solidFill>
               </a:rPr>
-              <a:t>Returns the starting recipe state or empty meal slot.</a:t>
+              <a:t>Human caterers cross-referencing allergen charts manually frequently cause deadly cross-contamination risks or compromise dish integrity.</a:t>
             </a:r>
           </a:p>
           <a:p>
             <a:pPr>
               <a:spcBef>
-                <a:spcPts val="800"/>
+                <a:spcPts val="1200"/>
               </a:spcBef>
-              <a:defRPr b="1" sz="1200">
-                <a:solidFill>
-                  <a:srgbClr val="38BDF8"/>
-                </a:solidFill>
-              </a:defRPr>
-            </a:pPr>
-            <a:r>
-              <a:t>actions(state)</a:t>
-            </a:r>
-            <a:br/>
-            <a:r>
-              <a:rPr b="0" sz="1100">
+              <a:defRPr b="1" sz="1300">
+                <a:solidFill>
+                  <a:srgbClr val="F8FAFC"/>
+                </a:solidFill>
+              </a:defRPr>
+            </a:pPr>
+            <a:r>
+              <a:t>• Combinatorial Package Explosion: </a:t>
+            </a:r>
+            <a:r>
+              <a:rPr b="0" sz="1200">
                 <a:solidFill>
                   <a:srgbClr val="94A3B8"/>
                 </a:solidFill>
               </a:rPr>
-              <a:t>Generates legal actions (ingredient swap or next course dish).</a:t>
+              <a:t>Selecting a 3-course package (Starter, Main, Dessert) from dozens of options creates hundreds of combinations, overwhelming manual event planners.</a:t>
             </a:r>
           </a:p>
           <a:p>
             <a:pPr>
               <a:spcBef>
-                <a:spcPts val="800"/>
+                <a:spcPts val="1200"/>
               </a:spcBef>
-              <a:defRPr b="1" sz="1200">
-                <a:solidFill>
-                  <a:srgbClr val="38BDF8"/>
-                </a:solidFill>
-              </a:defRPr>
-            </a:pPr>
-            <a:r>
-              <a:t>result(state, action)</a:t>
-            </a:r>
-            <a:br/>
-            <a:r>
-              <a:rPr b="0" sz="1100">
+              <a:defRPr b="1" sz="1300">
+                <a:solidFill>
+                  <a:srgbClr val="F8FAFC"/>
+                </a:solidFill>
+              </a:defRPr>
+            </a:pPr>
+            <a:r>
+              <a:t>• Constraint Conflicts: </a:t>
+            </a:r>
+            <a:r>
+              <a:rPr b="0" sz="1200">
                 <a:solidFill>
                   <a:srgbClr val="94A3B8"/>
                 </a:solidFill>
               </a:rPr>
-              <a:t>Computes transition to subsequent state.</a:t>
+              <a:t>Simultaneously balancing maximum per-head budget with minimum vegetarian and gluten-free quotas leads to trial-and-error delays.</a:t>
             </a:r>
           </a:p>
           <a:p>
             <a:pPr>
               <a:spcBef>
-                <a:spcPts val="800"/>
+                <a:spcPts val="1200"/>
               </a:spcBef>
-              <a:defRPr b="1" sz="1200">
-                <a:solidFill>
-                  <a:srgbClr val="38BDF8"/>
-                </a:solidFill>
-              </a:defRPr>
-            </a:pPr>
-            <a:r>
-              <a:t>is_goal(state)</a:t>
-            </a:r>
-            <a:br/>
-            <a:r>
-              <a:rPr b="0" sz="1100">
+              <a:defRPr b="1" sz="1300">
+                <a:solidFill>
+                  <a:srgbClr val="F8FAFC"/>
+                </a:solidFill>
+              </a:defRPr>
+            </a:pPr>
+            <a:r>
+              <a:t>• Lack of Performance Metrics: </a:t>
+            </a:r>
+            <a:r>
+              <a:rPr b="0" sz="1200">
                 <a:solidFill>
                   <a:srgbClr val="94A3B8"/>
                 </a:solidFill>
               </a:rPr>
-              <a:t>Verifies if goal state satisfies all allergen/course conditions.</a:t>
-            </a:r>
-          </a:p>
-          <a:p>
-            <a:pPr>
-              <a:spcBef>
-                <a:spcPts val="800"/>
-              </a:spcBef>
-              <a:defRPr b="1" sz="1200">
-                <a:solidFill>
-                  <a:srgbClr val="38BDF8"/>
-                </a:solidFill>
-              </a:defRPr>
-            </a:pPr>
-            <a:r>
-              <a:t>prune(state)</a:t>
-            </a:r>
-            <a:br/>
-            <a:r>
-              <a:rPr b="0" sz="1100">
-                <a:solidFill>
-                  <a:srgbClr val="94A3B8"/>
-                </a:solidFill>
-              </a:rPr>
-              <a:t>Backtracking hook: evaluates partial constraint violations.</a:t>
+              <a:t>Kitchens lack objective metrics to verify whether a proposed menu package represents the optimal allocation of ingredients.</a:t>
             </a:r>
           </a:p>
         </p:txBody>
@@ -4241,8 +4258,8 @@
         </p:nvSpPr>
         <p:spPr>
           <a:xfrm>
-            <a:off x="4434840" y="1554480"/>
-            <a:ext cx="3337560" cy="4754880"/>
+            <a:off x="6309360" y="1554480"/>
+            <a:ext cx="5120640" cy="4754880"/>
           </a:xfrm>
           <a:prstGeom prst="roundRect">
             <a:avLst/>
@@ -4286,8 +4303,8 @@
         </p:nvSpPr>
         <p:spPr>
           <a:xfrm>
-            <a:off x="4709159" y="1783080"/>
-            <a:ext cx="2788920" cy="411480"/>
+            <a:off x="6583680" y="1755648"/>
+            <a:ext cx="4572000" cy="411480"/>
           </a:xfrm>
           <a:prstGeom prst="rect">
             <a:avLst/>
@@ -4303,12 +4320,12 @@
             <a:pPr>
               <a:defRPr sz="1500" b="1">
                 <a:solidFill>
-                  <a:srgbClr val="6366F1"/>
-                </a:solidFill>
-              </a:defRPr>
-            </a:pPr>
-            <a:r>
-              <a:t>2. Node Bookkeeping</a:t>
+                  <a:srgbClr val="10B981"/>
+                </a:solidFill>
+              </a:defRPr>
+            </a:pPr>
+            <a:r>
+              <a:t>Key Application Objectives</a:t>
             </a:r>
           </a:p>
         </p:txBody>
@@ -4321,8 +4338,8 @@
         </p:nvSpPr>
         <p:spPr>
           <a:xfrm>
-            <a:off x="4663440" y="2194560"/>
-            <a:ext cx="2880360" cy="3840480"/>
+            <a:off x="6583680" y="2194560"/>
+            <a:ext cx="4572000" cy="3840480"/>
           </a:xfrm>
           <a:prstGeom prst="rect">
             <a:avLst/>
@@ -4336,329 +4353,91 @@
           <a:lstStyle/>
           <a:p>
             <a:pPr>
-              <a:defRPr b="1" sz="1200">
+              <a:defRPr b="1" sz="1300">
                 <a:solidFill>
                   <a:srgbClr val="F8FAFC"/>
                 </a:solidFill>
               </a:defRPr>
             </a:pPr>
             <a:r>
-              <a:t>• State vs Node Separation: </a:t>
-            </a:r>
-            <a:r>
-              <a:rPr b="0" sz="1100">
+              <a:t>• Objective 1: Allergen Safe-Path Search: </a:t>
+            </a:r>
+            <a:r>
+              <a:rPr b="0" sz="1200">
                 <a:solidFill>
                   <a:srgbClr val="94A3B8"/>
                 </a:solidFill>
               </a:rPr>
-              <a:t>A state represents world configuration; a Node is an active search tree bookkeeping structure.</a:t>
+              <a:t>Implement Breadth-First Search (BFS) on an ingredient graph to guarantee the minimal number of ingredient substitutions to eliminate allergens.</a:t>
             </a:r>
           </a:p>
           <a:p>
             <a:pPr>
               <a:spcBef>
-                <a:spcPts val="1000"/>
+                <a:spcPts val="1200"/>
               </a:spcBef>
-              <a:defRPr b="1" sz="1200">
+              <a:defRPr b="1" sz="1300">
                 <a:solidFill>
                   <a:srgbClr val="F8FAFC"/>
                 </a:solidFill>
               </a:defRPr>
             </a:pPr>
             <a:r>
-              <a:t>• parent pointer: </a:t>
-            </a:r>
-            <a:r>
-              <a:rPr b="0" sz="1100">
+              <a:t>• Objective 2: Constraint-Driven Menu Assembly: </a:t>
+            </a:r>
+            <a:r>
+              <a:rPr b="0" sz="1200">
                 <a:solidFill>
                   <a:srgbClr val="94A3B8"/>
                 </a:solidFill>
               </a:rPr>
-              <a:t>Tracks origin node to reconstruct full solution path from goal to root.</a:t>
+              <a:t>Implement Depth-First Search (DFS) with early branch pruning to assemble 3-course catering packages satisfying budget &amp; dietary limits.</a:t>
             </a:r>
           </a:p>
           <a:p>
             <a:pPr>
               <a:spcBef>
-                <a:spcPts val="1000"/>
+                <a:spcPts val="1200"/>
               </a:spcBef>
-              <a:defRPr b="1" sz="1200">
+              <a:defRPr b="1" sz="1300">
                 <a:solidFill>
                   <a:srgbClr val="F8FAFC"/>
                 </a:solidFill>
               </a:defRPr>
             </a:pPr>
             <a:r>
-              <a:t>• action: </a:t>
-            </a:r>
-            <a:r>
-              <a:rPr b="0" sz="1100">
+              <a:t>• Objective 3: Branch-and-Bound Efficiency: </a:t>
+            </a:r>
+            <a:r>
+              <a:rPr b="0" sz="1200">
                 <a:solidFill>
                   <a:srgbClr val="94A3B8"/>
                 </a:solidFill>
               </a:rPr>
-              <a:t>The transition taken from parent to generate this node.</a:t>
+              <a:t>Prune invalid partial menus early to reduce search tree node expansions by over 70% compared to brute-force evaluation.</a:t>
             </a:r>
           </a:p>
           <a:p>
             <a:pPr>
               <a:spcBef>
-                <a:spcPts val="1000"/>
+                <a:spcPts val="1200"/>
               </a:spcBef>
-              <a:defRPr b="1" sz="1200">
+              <a:defRPr b="1" sz="1300">
                 <a:solidFill>
                   <a:srgbClr val="F8FAFC"/>
                 </a:solidFill>
               </a:defRPr>
             </a:pPr>
             <a:r>
-              <a:t>• path_cost g(n): </a:t>
-            </a:r>
-            <a:r>
-              <a:rPr b="0" sz="1100">
+              <a:t>• Objective 4: Interactive Decision Studio: </a:t>
+            </a:r>
+            <a:r>
+              <a:rPr b="0" sz="1200">
                 <a:solidFill>
                   <a:srgbClr val="94A3B8"/>
                 </a:solidFill>
               </a:rPr>
-              <a:t>Cumulative path cost from start node.</a:t>
-            </a:r>
-          </a:p>
-          <a:p>
-            <a:pPr>
-              <a:spcBef>
-                <a:spcPts val="1000"/>
-              </a:spcBef>
-              <a:defRPr b="1" sz="1200">
-                <a:solidFill>
-                  <a:srgbClr val="F8FAFC"/>
-                </a:solidFill>
-              </a:defRPr>
-            </a:pPr>
-            <a:r>
-              <a:t>• depth: </a:t>
-            </a:r>
-            <a:r>
-              <a:rPr b="0" sz="1100">
-                <a:solidFill>
-                  <a:srgbClr val="94A3B8"/>
-                </a:solidFill>
-              </a:rPr>
-              <a:t>Integer depth level of the search tree.</a:t>
-            </a:r>
-          </a:p>
-        </p:txBody>
-      </p:sp>
-      <p:sp>
-        <p:nvSpPr>
-          <p:cNvPr id="11" name="Rounded Rectangle 10"/>
-          <p:cNvSpPr/>
-          <p:nvPr/>
-        </p:nvSpPr>
-        <p:spPr>
-          <a:xfrm>
-            <a:off x="8138160" y="1554480"/>
-            <a:ext cx="3337560" cy="4754880"/>
-          </a:xfrm>
-          <a:prstGeom prst="roundRect">
-            <a:avLst/>
-          </a:prstGeom>
-          <a:solidFill>
-            <a:srgbClr val="161E31"/>
-          </a:solidFill>
-          <a:ln w="15240">
-            <a:solidFill>
-              <a:srgbClr val="2D3752"/>
-            </a:solidFill>
-          </a:ln>
-        </p:spPr>
-        <p:style>
-          <a:lnRef idx="1">
-            <a:schemeClr val="accent1"/>
-          </a:lnRef>
-          <a:fillRef idx="3">
-            <a:schemeClr val="accent1"/>
-          </a:fillRef>
-          <a:effectRef idx="2">
-            <a:schemeClr val="accent1"/>
-          </a:effectRef>
-          <a:fontRef idx="minor">
-            <a:schemeClr val="lt1"/>
-          </a:fontRef>
-        </p:style>
-        <p:txBody>
-          <a:bodyPr rtlCol="0" anchor="ctr"/>
-          <a:lstStyle/>
-          <a:p>
-            <a:pPr algn="ctr"/>
-          </a:p>
-        </p:txBody>
-      </p:sp>
-      <p:sp>
-        <p:nvSpPr>
-          <p:cNvPr id="12" name="TextBox 11"/>
-          <p:cNvSpPr txBox="1"/>
-          <p:nvPr/>
-        </p:nvSpPr>
-        <p:spPr>
-          <a:xfrm>
-            <a:off x="8412480" y="1783080"/>
-            <a:ext cx="2788920" cy="411480"/>
-          </a:xfrm>
-          <a:prstGeom prst="rect">
-            <a:avLst/>
-          </a:prstGeom>
-          <a:noFill/>
-        </p:spPr>
-        <p:txBody>
-          <a:bodyPr wrap="square" lIns="0" tIns="0" rIns="0" bIns="0">
-            <a:spAutoFit/>
-          </a:bodyPr>
-          <a:lstStyle/>
-          <a:p>
-            <a:pPr>
-              <a:defRPr sz="1500" b="1">
-                <a:solidFill>
-                  <a:srgbClr val="10B981"/>
-                </a:solidFill>
-              </a:defRPr>
-            </a:pPr>
-            <a:r>
-              <a:t>3. SearchResult Container</a:t>
-            </a:r>
-          </a:p>
-        </p:txBody>
-      </p:sp>
-      <p:sp>
-        <p:nvSpPr>
-          <p:cNvPr id="13" name="TextBox 12"/>
-          <p:cNvSpPr txBox="1"/>
-          <p:nvPr/>
-        </p:nvSpPr>
-        <p:spPr>
-          <a:xfrm>
-            <a:off x="8366760" y="2194560"/>
-            <a:ext cx="2880360" cy="3840480"/>
-          </a:xfrm>
-          <a:prstGeom prst="rect">
-            <a:avLst/>
-          </a:prstGeom>
-          <a:noFill/>
-        </p:spPr>
-        <p:txBody>
-          <a:bodyPr wrap="square">
-            <a:spAutoFit/>
-          </a:bodyPr>
-          <a:lstStyle/>
-          <a:p>
-            <a:pPr>
-              <a:defRPr b="1" sz="1200">
-                <a:solidFill>
-                  <a:srgbClr val="F8FAFC"/>
-                </a:solidFill>
-              </a:defRPr>
-            </a:pPr>
-            <a:r>
-              <a:t>• solution_path: </a:t>
-            </a:r>
-            <a:r>
-              <a:rPr b="0" sz="1100">
-                <a:solidFill>
-                  <a:srgbClr val="94A3B8"/>
-                </a:solidFill>
-              </a:rPr>
-              <a:t>Ordered sequence of states from initial to goal.</a:t>
-            </a:r>
-          </a:p>
-          <a:p>
-            <a:pPr>
-              <a:spcBef>
-                <a:spcPts val="1000"/>
-              </a:spcBef>
-              <a:defRPr b="1" sz="1200">
-                <a:solidFill>
-                  <a:srgbClr val="F8FAFC"/>
-                </a:solidFill>
-              </a:defRPr>
-            </a:pPr>
-            <a:r>
-              <a:t>• nodes_expanded: </a:t>
-            </a:r>
-            <a:r>
-              <a:rPr b="0" sz="1100">
-                <a:solidFill>
-                  <a:srgbClr val="94A3B8"/>
-                </a:solidFill>
-              </a:rPr>
-              <a:t>Total number of nodes popped and tested from frontier.</a:t>
-            </a:r>
-          </a:p>
-          <a:p>
-            <a:pPr>
-              <a:spcBef>
-                <a:spcPts val="1000"/>
-              </a:spcBef>
-              <a:defRPr b="1" sz="1200">
-                <a:solidFill>
-                  <a:srgbClr val="F8FAFC"/>
-                </a:solidFill>
-              </a:defRPr>
-            </a:pPr>
-            <a:r>
-              <a:t>• nodes_generated: </a:t>
-            </a:r>
-            <a:r>
-              <a:rPr b="0" sz="1100">
-                <a:solidFill>
-                  <a:srgbClr val="94A3B8"/>
-                </a:solidFill>
-              </a:rPr>
-              <a:t>Total child nodes produced by action successors.</a:t>
-            </a:r>
-          </a:p>
-          <a:p>
-            <a:pPr>
-              <a:spcBef>
-                <a:spcPts val="1000"/>
-              </a:spcBef>
-              <a:defRPr b="1" sz="1200">
-                <a:solidFill>
-                  <a:srgbClr val="F8FAFC"/>
-                </a:solidFill>
-              </a:defRPr>
-            </a:pPr>
-            <a:r>
-              <a:t>• max_frontier_size: </a:t>
-            </a:r>
-            <a:r>
-              <a:rPr b="0" sz="1100">
-                <a:solidFill>
-                  <a:srgbClr val="94A3B8"/>
-                </a:solidFill>
-              </a:rPr>
-              <a:t>Peak queue/stack memory occupancy during search.</a:t>
-            </a:r>
-          </a:p>
-          <a:p>
-            <a:pPr>
-              <a:spcBef>
-                <a:spcPts val="1000"/>
-              </a:spcBef>
-              <a:defRPr b="1" sz="1200">
-                <a:solidFill>
-                  <a:srgbClr val="F8FAFC"/>
-                </a:solidFill>
-              </a:defRPr>
-            </a:pPr>
-            <a:r>
-              <a:t>• runtime_ms: </a:t>
-            </a:r>
-            <a:r>
-              <a:rPr b="0" sz="1100">
-                <a:solidFill>
-                  <a:srgbClr val="94A3B8"/>
-                </a:solidFill>
-              </a:rPr>
-              <a:t>High-precision execution time measured in milliseconds.</a:t>
+              <a:t>Provide interactive Streamlit dashboards with live metric inspection (nodes expanded, execution time in ms, search depth).</a:t>
             </a:r>
           </a:p>
         </p:txBody>
@@ -4732,7 +4511,7 @@
         </p:nvSpPr>
         <p:spPr>
           <a:xfrm>
-            <a:off x="731520" y="411480"/>
+            <a:off x="731520" y="365760"/>
             <a:ext cx="10698480" cy="320040"/>
           </a:xfrm>
           <a:prstGeom prst="rect">
@@ -4754,7 +4533,7 @@
               </a:defRPr>
             </a:pPr>
             <a:r>
-              <a:t>LAB 04: UNINFORMED SEARCH (FIFO QUEUE)</a:t>
+              <a:t>SECTION 3: SYLLABUS CONCEPTS &amp; THEIR DIRECT APPLICATION</a:t>
             </a:r>
           </a:p>
         </p:txBody>
@@ -4767,7 +4546,7 @@
         </p:nvSpPr>
         <p:spPr>
           <a:xfrm>
-            <a:off x="731520" y="685800"/>
+            <a:off x="731520" y="658368"/>
             <a:ext cx="10698480" cy="640080"/>
           </a:xfrm>
           <a:prstGeom prst="rect">
@@ -4782,14 +4561,14 @@
           <a:lstStyle/>
           <a:p>
             <a:pPr>
-              <a:defRPr sz="2400" b="1">
+              <a:defRPr sz="2300" b="1">
                 <a:solidFill>
                   <a:srgbClr val="F8FAFC"/>
                 </a:solidFill>
               </a:defRPr>
             </a:pPr>
             <a:r>
-              <a:t>Module A: Breadth-First Search (BFS) for Allergen Safe-Paths</a:t>
+              <a:t>3. Concepts Used (Labs 01–05)</a:t>
             </a:r>
           </a:p>
         </p:txBody>
@@ -4803,7 +4582,7 @@
         <p:spPr>
           <a:xfrm>
             <a:off x="731520" y="1554480"/>
-            <a:ext cx="5120640" cy="4754880"/>
+            <a:ext cx="3337560" cy="4754880"/>
           </a:xfrm>
           <a:prstGeom prst="roundRect">
             <a:avLst/>
@@ -4847,8 +4626,8 @@
         </p:nvSpPr>
         <p:spPr>
           <a:xfrm>
-            <a:off x="1005840" y="1783080"/>
-            <a:ext cx="4572000" cy="411480"/>
+            <a:off x="1005840" y="1755648"/>
+            <a:ext cx="2788920" cy="411480"/>
           </a:xfrm>
           <a:prstGeom prst="rect">
             <a:avLst/>
@@ -4864,12 +4643,12 @@
             <a:pPr>
               <a:defRPr sz="1500" b="1">
                 <a:solidFill>
-                  <a:srgbClr val="6366F1"/>
-                </a:solidFill>
-              </a:defRPr>
-            </a:pPr>
-            <a:r>
-              <a:t>Algorithmic Mechanics (bfs.py)</a:t>
+                  <a:srgbClr val="38BDF8"/>
+                </a:solidFill>
+              </a:defRPr>
+            </a:pPr>
+            <a:r>
+              <a:t>Labs 01 &amp; 02: OOP &amp; Search Abstraction</a:t>
             </a:r>
           </a:p>
         </p:txBody>
@@ -4882,8 +4661,8 @@
         </p:nvSpPr>
         <p:spPr>
           <a:xfrm>
-            <a:off x="1005840" y="2194560"/>
-            <a:ext cx="4572000" cy="3840480"/>
+            <a:off x="960120" y="2194560"/>
+            <a:ext cx="2880360" cy="3840480"/>
           </a:xfrm>
           <a:prstGeom prst="rect">
             <a:avLst/>
@@ -4897,91 +4676,95 @@
           <a:lstStyle/>
           <a:p>
             <a:pPr>
-              <a:defRPr b="1" sz="1300">
+              <a:defRPr b="1" sz="1150">
                 <a:solidFill>
                   <a:srgbClr val="F8FAFC"/>
                 </a:solidFill>
               </a:defRPr>
             </a:pPr>
             <a:r>
-              <a:t>• FIFO Frontier (collections.deque): </a:t>
-            </a:r>
-            <a:r>
-              <a:rPr b="0" sz="1200">
+              <a:t>• Russell &amp; Norvig Problem Base Class:</a:t>
+            </a:r>
+            <a:br/>
+            <a:r>
+              <a:rPr b="0" sz="1050">
                 <a:solidFill>
                   <a:srgbClr val="94A3B8"/>
                 </a:solidFill>
               </a:rPr>
-              <a:t>Nodes explored in shallowest-first sequence using O(1) amortized popleft() and append().</a:t>
+              <a:t>Abstract methods: initial_state(), actions(), result(), is_goal(), and prune().</a:t>
             </a:r>
           </a:p>
           <a:p>
             <a:pPr>
               <a:spcBef>
-                <a:spcPts val="1200"/>
+                <a:spcPts val="800"/>
               </a:spcBef>
-              <a:defRPr b="1" sz="1300">
+              <a:defRPr b="1" sz="1150">
                 <a:solidFill>
                   <a:srgbClr val="F8FAFC"/>
                 </a:solidFill>
               </a:defRPr>
             </a:pPr>
             <a:r>
-              <a:t>• Explored Set Tracking: </a:t>
-            </a:r>
-            <a:r>
-              <a:rPr b="0" sz="1200">
+              <a:t>• Node Bookkeeping Class:</a:t>
+            </a:r>
+            <a:br/>
+            <a:r>
+              <a:rPr b="0" sz="1050">
                 <a:solidFill>
                   <a:srgbClr val="94A3B8"/>
                 </a:solidFill>
               </a:rPr>
-              <a:t>Maintains visited frozenset states to eliminate cycles and redundant paths.</a:t>
+              <a:t>Tracks parent pointers, actions taken, path_cost g(n), and depth level to reconstruct full solution paths.</a:t>
             </a:r>
           </a:p>
           <a:p>
             <a:pPr>
               <a:spcBef>
-                <a:spcPts val="1200"/>
+                <a:spcPts val="800"/>
               </a:spcBef>
-              <a:defRPr b="1" sz="1300">
+              <a:defRPr b="1" sz="1150">
                 <a:solidFill>
                   <a:srgbClr val="F8FAFC"/>
                 </a:solidFill>
               </a:defRPr>
             </a:pPr>
             <a:r>
-              <a:t>• Mathematical Optimality: </a:t>
-            </a:r>
-            <a:r>
-              <a:rPr b="0" sz="1200">
+              <a:t>• SearchResult Container:</a:t>
+            </a:r>
+            <a:br/>
+            <a:r>
+              <a:rPr b="0" sz="1050">
                 <a:solidFill>
                   <a:srgbClr val="94A3B8"/>
                 </a:solidFill>
               </a:rPr>
-              <a:t>Because every ingredient swap has uniform step cost (c = 1.0), BFS guarantees finding the minimum number of swaps.</a:t>
+              <a:t>Stores nodes expanded, nodes generated, max frontier size, and runtime in ms.</a:t>
             </a:r>
           </a:p>
           <a:p>
             <a:pPr>
               <a:spcBef>
-                <a:spcPts val="1200"/>
+                <a:spcPts val="800"/>
               </a:spcBef>
-              <a:defRPr b="1" sz="1300">
+              <a:defRPr b="1" sz="1150">
                 <a:solidFill>
                   <a:srgbClr val="F8FAFC"/>
                 </a:solidFill>
               </a:defRPr>
             </a:pPr>
             <a:r>
-              <a:t>• Completeness: </a:t>
-            </a:r>
-            <a:r>
-              <a:rPr b="0" sz="1200">
+              <a:t>• In-Memory Graphs (data.py):</a:t>
+            </a:r>
+            <a:br/>
+            <a:r>
+              <a:rPr b="0" sz="1050">
                 <a:solidFill>
                   <a:srgbClr val="94A3B8"/>
                 </a:solidFill>
               </a:rPr>
-              <a:t>Guaranteed to find a safe ingredient combination if one exists in the graph.</a:t>
+              <a:t>Pure Python dictionaries, sets, and lists modeling adjacency graphs without database overhead.</a:t>
             </a:r>
           </a:p>
         </p:txBody>
@@ -4994,8 +4777,8 @@
         </p:nvSpPr>
         <p:spPr>
           <a:xfrm>
-            <a:off x="6309360" y="1554480"/>
-            <a:ext cx="5120640" cy="4754880"/>
+            <a:off x="4434840" y="1554480"/>
+            <a:ext cx="3337560" cy="4754880"/>
           </a:xfrm>
           <a:prstGeom prst="roundRect">
             <a:avLst/>
@@ -5039,8 +4822,8 @@
         </p:nvSpPr>
         <p:spPr>
           <a:xfrm>
-            <a:off x="6583680" y="1783080"/>
-            <a:ext cx="4572000" cy="411480"/>
+            <a:off x="4709159" y="1755648"/>
+            <a:ext cx="2788920" cy="411480"/>
           </a:xfrm>
           <a:prstGeom prst="rect">
             <a:avLst/>
@@ -5056,12 +4839,12 @@
             <a:pPr>
               <a:defRPr sz="1500" b="1">
                 <a:solidFill>
-                  <a:srgbClr val="38BDF8"/>
-                </a:solidFill>
-              </a:defRPr>
-            </a:pPr>
-            <a:r>
-              <a:t>Live Catering Problem Formulation</a:t>
+                  <a:srgbClr val="6366F1"/>
+                </a:solidFill>
+              </a:defRPr>
+            </a:pPr>
+            <a:r>
+              <a:t>Labs 03 &amp; 04: Breadth-First Search (BFS)</a:t>
             </a:r>
           </a:p>
         </p:txBody>
@@ -5074,8 +4857,8 @@
         </p:nvSpPr>
         <p:spPr>
           <a:xfrm>
-            <a:off x="6583680" y="2194560"/>
-            <a:ext cx="4572000" cy="3840480"/>
+            <a:off x="4663440" y="2194560"/>
+            <a:ext cx="2880360" cy="3840480"/>
           </a:xfrm>
           <a:prstGeom prst="rect">
             <a:avLst/>
@@ -5089,91 +4872,291 @@
           <a:lstStyle/>
           <a:p>
             <a:pPr>
-              <a:defRPr b="1" sz="1300">
+              <a:defRPr b="1" sz="1150">
                 <a:solidFill>
                   <a:srgbClr val="F8FAFC"/>
                 </a:solidFill>
               </a:defRPr>
             </a:pPr>
             <a:r>
-              <a:t>• State Representation: </a:t>
-            </a:r>
-            <a:r>
-              <a:rPr b="0" sz="1200">
+              <a:t>• FIFO Queue Frontier:</a:t>
+            </a:r>
+            <a:br/>
+            <a:r>
+              <a:rPr b="0" sz="1050">
                 <a:solidFill>
                   <a:srgbClr val="94A3B8"/>
                 </a:solidFill>
               </a:rPr>
-              <a:t>frozenset of recipe ingredients (e.g. {'Chicken', 'Peanut Butter', 'Soy Sauce'}).</a:t>
+              <a:t>Implemented with collections.deque for O(1) amortized append() and popleft() operations.</a:t>
             </a:r>
           </a:p>
           <a:p>
             <a:pPr>
               <a:spcBef>
-                <a:spcPts val="1200"/>
+                <a:spcPts val="800"/>
               </a:spcBef>
-              <a:defRPr b="1" sz="1300">
+              <a:defRPr b="1" sz="1150">
                 <a:solidFill>
                   <a:srgbClr val="F8FAFC"/>
                 </a:solidFill>
               </a:defRPr>
             </a:pPr>
             <a:r>
-              <a:t>• Goal Condition: </a:t>
-            </a:r>
-            <a:r>
-              <a:rPr b="0" sz="1200">
+              <a:t>• Explored Set Cycle Detection:</a:t>
+            </a:r>
+            <a:br/>
+            <a:r>
+              <a:rPr b="0" sz="1050">
                 <a:solidFill>
                   <a:srgbClr val="94A3B8"/>
                 </a:solidFill>
               </a:rPr>
-              <a:t>is_goal(state) returns True when no ingredient contains any target client allergens.</a:t>
+              <a:t>Maintains visited frozenset states to prevent infinite loops in cyclic substitution graphs.</a:t>
             </a:r>
           </a:p>
           <a:p>
             <a:pPr>
               <a:spcBef>
-                <a:spcPts val="1200"/>
+                <a:spcPts val="800"/>
               </a:spcBef>
-              <a:defRPr b="1" sz="1300">
+              <a:defRPr b="1" sz="1150">
                 <a:solidFill>
                   <a:srgbClr val="F8FAFC"/>
                 </a:solidFill>
               </a:defRPr>
             </a:pPr>
             <a:r>
-              <a:t>• Live Event Scenario: </a:t>
-            </a:r>
-            <a:r>
-              <a:rPr b="0" sz="1200">
+              <a:t>• Unit-Cost Optimality:</a:t>
+            </a:r>
+            <a:br/>
+            <a:r>
+              <a:rPr b="0" sz="1050">
                 <a:solidFill>
                   <a:srgbClr val="94A3B8"/>
                 </a:solidFill>
               </a:rPr>
-              <a:t>TechCorp Summit: Keynote speaker with severe peanut anaphylaxis requested Thai Satay Skewers.</a:t>
+              <a:t>Since every ingredient swap has uniform cost (c = 1.0), BFS mathematically guarantees the shortest swap chain.</a:t>
             </a:r>
           </a:p>
           <a:p>
             <a:pPr>
               <a:spcBef>
-                <a:spcPts val="1200"/>
+                <a:spcPts val="800"/>
               </a:spcBef>
-              <a:defRPr b="1" sz="1300">
+              <a:defRPr b="1" sz="1150">
                 <a:solidFill>
                   <a:srgbClr val="F8FAFC"/>
                 </a:solidFill>
               </a:defRPr>
             </a:pPr>
             <a:r>
-              <a:t>• Optimal AI Solution: </a:t>
-            </a:r>
-            <a:r>
-              <a:rPr b="0" sz="1200">
+              <a:t>• Catering Application:</a:t>
+            </a:r>
+            <a:br/>
+            <a:r>
+              <a:rPr b="0" sz="1050">
                 <a:solidFill>
                   <a:srgbClr val="94A3B8"/>
                 </a:solidFill>
               </a:rPr>
-              <a:t>Peanut Butter  --&gt;  Sunflower Seed Butter (1 swap, 2 nodes expanded, 0.12 ms). Original dish flavor retained!</a:t>
+              <a:t>Finds the exact minimum ingredient swaps required to make recipes 100% allergen safe.</a:t>
+            </a:r>
+          </a:p>
+        </p:txBody>
+      </p:sp>
+      <p:sp>
+        <p:nvSpPr>
+          <p:cNvPr id="11" name="Rounded Rectangle 10"/>
+          <p:cNvSpPr/>
+          <p:nvPr/>
+        </p:nvSpPr>
+        <p:spPr>
+          <a:xfrm>
+            <a:off x="8138160" y="1554480"/>
+            <a:ext cx="3337560" cy="4754880"/>
+          </a:xfrm>
+          <a:prstGeom prst="roundRect">
+            <a:avLst/>
+          </a:prstGeom>
+          <a:solidFill>
+            <a:srgbClr val="161E31"/>
+          </a:solidFill>
+          <a:ln w="15240">
+            <a:solidFill>
+              <a:srgbClr val="2D3752"/>
+            </a:solidFill>
+          </a:ln>
+        </p:spPr>
+        <p:style>
+          <a:lnRef idx="1">
+            <a:schemeClr val="accent1"/>
+          </a:lnRef>
+          <a:fillRef idx="3">
+            <a:schemeClr val="accent1"/>
+          </a:fillRef>
+          <a:effectRef idx="2">
+            <a:schemeClr val="accent1"/>
+          </a:effectRef>
+          <a:fontRef idx="minor">
+            <a:schemeClr val="lt1"/>
+          </a:fontRef>
+        </p:style>
+        <p:txBody>
+          <a:bodyPr rtlCol="0" anchor="ctr"/>
+          <a:lstStyle/>
+          <a:p>
+            <a:pPr algn="ctr"/>
+          </a:p>
+        </p:txBody>
+      </p:sp>
+      <p:sp>
+        <p:nvSpPr>
+          <p:cNvPr id="12" name="TextBox 11"/>
+          <p:cNvSpPr txBox="1"/>
+          <p:nvPr/>
+        </p:nvSpPr>
+        <p:spPr>
+          <a:xfrm>
+            <a:off x="8412480" y="1755648"/>
+            <a:ext cx="2788920" cy="411480"/>
+          </a:xfrm>
+          <a:prstGeom prst="rect">
+            <a:avLst/>
+          </a:prstGeom>
+          <a:noFill/>
+        </p:spPr>
+        <p:txBody>
+          <a:bodyPr wrap="square" lIns="0" tIns="0" rIns="0" bIns="0">
+            <a:spAutoFit/>
+          </a:bodyPr>
+          <a:lstStyle/>
+          <a:p>
+            <a:pPr>
+              <a:defRPr sz="1500" b="1">
+                <a:solidFill>
+                  <a:srgbClr val="10B981"/>
+                </a:solidFill>
+              </a:defRPr>
+            </a:pPr>
+            <a:r>
+              <a:t>Lab 05: Depth-First Search &amp; Pruning</a:t>
+            </a:r>
+          </a:p>
+        </p:txBody>
+      </p:sp>
+      <p:sp>
+        <p:nvSpPr>
+          <p:cNvPr id="13" name="TextBox 12"/>
+          <p:cNvSpPr txBox="1"/>
+          <p:nvPr/>
+        </p:nvSpPr>
+        <p:spPr>
+          <a:xfrm>
+            <a:off x="8366760" y="2194560"/>
+            <a:ext cx="2880360" cy="3840480"/>
+          </a:xfrm>
+          <a:prstGeom prst="rect">
+            <a:avLst/>
+          </a:prstGeom>
+          <a:noFill/>
+        </p:spPr>
+        <p:txBody>
+          <a:bodyPr wrap="square">
+            <a:spAutoFit/>
+          </a:bodyPr>
+          <a:lstStyle/>
+          <a:p>
+            <a:pPr>
+              <a:defRPr b="1" sz="1150">
+                <a:solidFill>
+                  <a:srgbClr val="F8FAFC"/>
+                </a:solidFill>
+              </a:defRPr>
+            </a:pPr>
+            <a:r>
+              <a:t>• LIFO Stack Frontier:</a:t>
+            </a:r>
+            <a:br/>
+            <a:r>
+              <a:rPr b="0" sz="1050">
+                <a:solidFill>
+                  <a:srgbClr val="94A3B8"/>
+                </a:solidFill>
+              </a:rPr>
+              <a:t>Implemented via standard Python list (pop() and append()) exploring deep candidate paths first.</a:t>
+            </a:r>
+          </a:p>
+          <a:p>
+            <a:pPr>
+              <a:spcBef>
+                <a:spcPts val="800"/>
+              </a:spcBef>
+              <a:defRPr b="1" sz="1150">
+                <a:solidFill>
+                  <a:srgbClr val="F8FAFC"/>
+                </a:solidFill>
+              </a:defRPr>
+            </a:pPr>
+            <a:r>
+              <a:t>• Linear Space Complexity:</a:t>
+            </a:r>
+            <a:br/>
+            <a:r>
+              <a:rPr b="0" sz="1050">
+                <a:solidFill>
+                  <a:srgbClr val="94A3B8"/>
+                </a:solidFill>
+              </a:rPr>
+              <a:t>Consumes O(b * m) memory instead of exponential O(b^d), making it ideal for fixed course depths.</a:t>
+            </a:r>
+          </a:p>
+          <a:p>
+            <a:pPr>
+              <a:spcBef>
+                <a:spcPts val="800"/>
+              </a:spcBef>
+              <a:defRPr b="1" sz="1150">
+                <a:solidFill>
+                  <a:srgbClr val="F8FAFC"/>
+                </a:solidFill>
+              </a:defRPr>
+            </a:pPr>
+            <a:r>
+              <a:t>• Branch-and-Bound Pruning:</a:t>
+            </a:r>
+            <a:br/>
+            <a:r>
+              <a:rPr b="0" sz="1050">
+                <a:solidFill>
+                  <a:srgbClr val="94A3B8"/>
+                </a:solidFill>
+              </a:rPr>
+              <a:t>Early prune() check discards partial states exceeding budget or violating remaining course dietary limits.</a:t>
+            </a:r>
+          </a:p>
+          <a:p>
+            <a:pPr>
+              <a:spcBef>
+                <a:spcPts val="800"/>
+              </a:spcBef>
+              <a:defRPr b="1" sz="1150">
+                <a:solidFill>
+                  <a:srgbClr val="F8FAFC"/>
+                </a:solidFill>
+              </a:defRPr>
+            </a:pPr>
+            <a:r>
+              <a:t>• Catering Application:</a:t>
+            </a:r>
+            <a:br/>
+            <a:r>
+              <a:rPr b="0" sz="1050">
+                <a:solidFill>
+                  <a:srgbClr val="94A3B8"/>
+                </a:solidFill>
+              </a:rPr>
+              <a:t>Assembles 3-course menus (Starter, Main, Dessert) fulfilling budget and dietary quotas with zero wasted compute.</a:t>
             </a:r>
           </a:p>
         </p:txBody>
@@ -5247,7 +5230,7 @@
         </p:nvSpPr>
         <p:spPr>
           <a:xfrm>
-            <a:off x="731520" y="411480"/>
+            <a:off x="731520" y="365760"/>
             <a:ext cx="10698480" cy="320040"/>
           </a:xfrm>
           <a:prstGeom prst="rect">
@@ -5269,7 +5252,7 @@
               </a:defRPr>
             </a:pPr>
             <a:r>
-              <a:t>LAB 05: UNINFORMED SEARCH &amp; BACKTRACKING (LIFO STACK)</a:t>
+              <a:t>SECTION 4: SYSTEM ARCHITECTURE &amp; EXECUTION PIPELINE</a:t>
             </a:r>
           </a:p>
         </p:txBody>
@@ -5282,7 +5265,7 @@
         </p:nvSpPr>
         <p:spPr>
           <a:xfrm>
-            <a:off x="731520" y="685800"/>
+            <a:off x="731520" y="658368"/>
             <a:ext cx="10698480" cy="640080"/>
           </a:xfrm>
           <a:prstGeom prst="rect">
@@ -5297,14 +5280,14 @@
           <a:lstStyle/>
           <a:p>
             <a:pPr>
-              <a:defRPr sz="2400" b="1">
+              <a:defRPr sz="2300" b="1">
                 <a:solidFill>
                   <a:srgbClr val="F8FAFC"/>
                 </a:solidFill>
               </a:defRPr>
             </a:pPr>
             <a:r>
-              <a:t>Module B: Depth-First Search (DFS) with Early Pruning</a:t>
+              <a:t>4. Proposed Design &amp; Working: Program Flow &amp; Architecture</a:t>
             </a:r>
           </a:p>
         </p:txBody>
@@ -5318,7 +5301,7 @@
         <p:spPr>
           <a:xfrm>
             <a:off x="731520" y="1554480"/>
-            <a:ext cx="5120640" cy="4754880"/>
+            <a:ext cx="2468880" cy="2286000"/>
           </a:xfrm>
           <a:prstGeom prst="roundRect">
             <a:avLst/>
@@ -5362,8 +5345,8 @@
         </p:nvSpPr>
         <p:spPr>
           <a:xfrm>
-            <a:off x="1005840" y="1783080"/>
-            <a:ext cx="4572000" cy="411480"/>
+            <a:off x="1005840" y="1755648"/>
+            <a:ext cx="1920240" cy="411480"/>
           </a:xfrm>
           <a:prstGeom prst="rect">
             <a:avLst/>
@@ -5379,12 +5362,12 @@
             <a:pPr>
               <a:defRPr sz="1500" b="1">
                 <a:solidFill>
-                  <a:srgbClr val="F59E0B"/>
-                </a:solidFill>
-              </a:defRPr>
-            </a:pPr>
-            <a:r>
-              <a:t>Algorithmic Mechanics (dfs.py)</a:t>
+                  <a:srgbClr val="6366F1"/>
+                </a:solidFill>
+              </a:defRPr>
+            </a:pPr>
+            <a:r>
+              <a:t>Step 1: Event Request</a:t>
             </a:r>
           </a:p>
         </p:txBody>
@@ -5397,8 +5380,8 @@
         </p:nvSpPr>
         <p:spPr>
           <a:xfrm>
-            <a:off x="1005840" y="2194560"/>
-            <a:ext cx="4572000" cy="3840480"/>
+            <a:off x="914400" y="2103120"/>
+            <a:ext cx="2103120" cy="1554480"/>
           </a:xfrm>
           <a:prstGeom prst="rect">
             <a:avLst/>
@@ -5412,91 +5395,14 @@
           <a:lstStyle/>
           <a:p>
             <a:pPr>
-              <a:defRPr b="1" sz="1300">
-                <a:solidFill>
-                  <a:srgbClr val="F8FAFC"/>
-                </a:solidFill>
-              </a:defRPr>
-            </a:pPr>
-            <a:r>
-              <a:t>• LIFO Frontier (stack.pop()): </a:t>
-            </a:r>
-            <a:r>
-              <a:rPr b="0" sz="1200">
+              <a:defRPr sz="1100">
                 <a:solidFill>
                   <a:srgbClr val="94A3B8"/>
                 </a:solidFill>
-              </a:rPr>
-              <a:t>Explores deepest branches first. Linear memory footprint O(b * m) vs BFS exponential O(b^d).</a:t>
-            </a:r>
-          </a:p>
-          <a:p>
-            <a:pPr>
-              <a:spcBef>
-                <a:spcPts val="1200"/>
-              </a:spcBef>
-              <a:defRPr b="1" sz="1300">
-                <a:solidFill>
-                  <a:srgbClr val="F8FAFC"/>
-                </a:solidFill>
-              </a:defRPr>
-            </a:pPr>
-            <a:r>
-              <a:t>• Branch-and-Bound Pruning: </a:t>
-            </a:r>
-            <a:r>
-              <a:rPr b="0" sz="1200">
-                <a:solidFill>
-                  <a:srgbClr val="94A3B8"/>
-                </a:solidFill>
-              </a:rPr>
-              <a:t>Evaluates problem.prune(child_state) before pushing child to stack. Avoids expanding doomed subtrees.</a:t>
-            </a:r>
-          </a:p>
-          <a:p>
-            <a:pPr>
-              <a:spcBef>
-                <a:spcPts val="1200"/>
-              </a:spcBef>
-              <a:defRPr b="1" sz="1300">
-                <a:solidFill>
-                  <a:srgbClr val="F8FAFC"/>
-                </a:solidFill>
-              </a:defRPr>
-            </a:pPr>
-            <a:r>
-              <a:t>• Multi-Solution Exploration: </a:t>
-            </a:r>
-            <a:r>
-              <a:rPr b="0" sz="1200">
-                <a:solidFill>
-                  <a:srgbClr val="94A3B8"/>
-                </a:solidFill>
-              </a:rPr>
-              <a:t>Configurable find_all=True collects multiple valid client quotation packages ranked by budget utilization.</a:t>
-            </a:r>
-          </a:p>
-          <a:p>
-            <a:pPr>
-              <a:spcBef>
-                <a:spcPts val="1200"/>
-              </a:spcBef>
-              <a:defRPr b="1" sz="1300">
-                <a:solidFill>
-                  <a:srgbClr val="F8FAFC"/>
-                </a:solidFill>
-              </a:defRPr>
-            </a:pPr>
-            <a:r>
-              <a:t>• Completeness in Finite Trees: </a:t>
-            </a:r>
-            <a:r>
-              <a:rPr b="0" sz="1200">
-                <a:solidFill>
-                  <a:srgbClr val="94A3B8"/>
-                </a:solidFill>
-              </a:rPr>
-              <a:t>Menu problem depth is strictly bound by courses (depth = 3), guaranteeing termination.</a:t>
+              </a:defRPr>
+            </a:pPr>
+            <a:r>
+              <a:t>Client submits guest count, target allergens, budget/head, and dietary quotas.</a:t>
             </a:r>
           </a:p>
         </p:txBody>
@@ -5509,8 +5415,8 @@
         </p:nvSpPr>
         <p:spPr>
           <a:xfrm>
-            <a:off x="6309360" y="1554480"/>
-            <a:ext cx="5120640" cy="4754880"/>
+            <a:off x="3429000" y="1554480"/>
+            <a:ext cx="2468880" cy="2286000"/>
           </a:xfrm>
           <a:prstGeom prst="roundRect">
             <a:avLst/>
@@ -5554,8 +5460,8 @@
         </p:nvSpPr>
         <p:spPr>
           <a:xfrm>
-            <a:off x="6583680" y="1783080"/>
-            <a:ext cx="4572000" cy="411480"/>
+            <a:off x="3703320" y="1755648"/>
+            <a:ext cx="1920240" cy="411480"/>
           </a:xfrm>
           <a:prstGeom prst="rect">
             <a:avLst/>
@@ -5571,12 +5477,12 @@
             <a:pPr>
               <a:defRPr sz="1500" b="1">
                 <a:solidFill>
-                  <a:srgbClr val="10B981"/>
-                </a:solidFill>
-              </a:defRPr>
-            </a:pPr>
-            <a:r>
-              <a:t>Menu Constraints &amp; Pruning Criteria</a:t>
+                  <a:srgbClr val="38BDF8"/>
+                </a:solidFill>
+              </a:defRPr>
+            </a:pPr>
+            <a:r>
+              <a:t>Step 2: State Formulation</a:t>
             </a:r>
           </a:p>
         </p:txBody>
@@ -5589,8 +5495,8 @@
         </p:nvSpPr>
         <p:spPr>
           <a:xfrm>
-            <a:off x="6583680" y="2194560"/>
-            <a:ext cx="4572000" cy="3840480"/>
+            <a:off x="3611880" y="2103120"/>
+            <a:ext cx="2103120" cy="1554480"/>
           </a:xfrm>
           <a:prstGeom prst="rect">
             <a:avLst/>
@@ -5604,91 +5510,436 @@
           <a:lstStyle/>
           <a:p>
             <a:pPr>
-              <a:defRPr b="1" sz="1300">
+              <a:defRPr sz="1100">
+                <a:solidFill>
+                  <a:srgbClr val="94A3B8"/>
+                </a:solidFill>
+              </a:defRPr>
+            </a:pPr>
+            <a:r>
+              <a:t>Problem defines initial_state, actions, transition result, and goal constraints.</a:t>
+            </a:r>
+          </a:p>
+        </p:txBody>
+      </p:sp>
+      <p:sp>
+        <p:nvSpPr>
+          <p:cNvPr id="11" name="Rounded Rectangle 10"/>
+          <p:cNvSpPr/>
+          <p:nvPr/>
+        </p:nvSpPr>
+        <p:spPr>
+          <a:xfrm>
+            <a:off x="6126480" y="1554480"/>
+            <a:ext cx="2468880" cy="2286000"/>
+          </a:xfrm>
+          <a:prstGeom prst="roundRect">
+            <a:avLst/>
+          </a:prstGeom>
+          <a:solidFill>
+            <a:srgbClr val="161E31"/>
+          </a:solidFill>
+          <a:ln w="15240">
+            <a:solidFill>
+              <a:srgbClr val="2D3752"/>
+            </a:solidFill>
+          </a:ln>
+        </p:spPr>
+        <p:style>
+          <a:lnRef idx="1">
+            <a:schemeClr val="accent1"/>
+          </a:lnRef>
+          <a:fillRef idx="3">
+            <a:schemeClr val="accent1"/>
+          </a:fillRef>
+          <a:effectRef idx="2">
+            <a:schemeClr val="accent1"/>
+          </a:effectRef>
+          <a:fontRef idx="minor">
+            <a:schemeClr val="lt1"/>
+          </a:fontRef>
+        </p:style>
+        <p:txBody>
+          <a:bodyPr rtlCol="0" anchor="ctr"/>
+          <a:lstStyle/>
+          <a:p>
+            <a:pPr algn="ctr"/>
+          </a:p>
+        </p:txBody>
+      </p:sp>
+      <p:sp>
+        <p:nvSpPr>
+          <p:cNvPr id="12" name="TextBox 11"/>
+          <p:cNvSpPr txBox="1"/>
+          <p:nvPr/>
+        </p:nvSpPr>
+        <p:spPr>
+          <a:xfrm>
+            <a:off x="6400800" y="1755648"/>
+            <a:ext cx="1920240" cy="411480"/>
+          </a:xfrm>
+          <a:prstGeom prst="rect">
+            <a:avLst/>
+          </a:prstGeom>
+          <a:noFill/>
+        </p:spPr>
+        <p:txBody>
+          <a:bodyPr wrap="square" lIns="0" tIns="0" rIns="0" bIns="0">
+            <a:spAutoFit/>
+          </a:bodyPr>
+          <a:lstStyle/>
+          <a:p>
+            <a:pPr>
+              <a:defRPr sz="1500" b="1">
+                <a:solidFill>
+                  <a:srgbClr val="F59E0B"/>
+                </a:solidFill>
+              </a:defRPr>
+            </a:pPr>
+            <a:r>
+              <a:t>Step 3: State-Space Search</a:t>
+            </a:r>
+          </a:p>
+        </p:txBody>
+      </p:sp>
+      <p:sp>
+        <p:nvSpPr>
+          <p:cNvPr id="13" name="TextBox 12"/>
+          <p:cNvSpPr txBox="1"/>
+          <p:nvPr/>
+        </p:nvSpPr>
+        <p:spPr>
+          <a:xfrm>
+            <a:off x="6309360" y="2103120"/>
+            <a:ext cx="2103120" cy="1554480"/>
+          </a:xfrm>
+          <a:prstGeom prst="rect">
+            <a:avLst/>
+          </a:prstGeom>
+          <a:noFill/>
+        </p:spPr>
+        <p:txBody>
+          <a:bodyPr wrap="square">
+            <a:spAutoFit/>
+          </a:bodyPr>
+          <a:lstStyle/>
+          <a:p>
+            <a:pPr>
+              <a:defRPr sz="1100">
+                <a:solidFill>
+                  <a:srgbClr val="94A3B8"/>
+                </a:solidFill>
+              </a:defRPr>
+            </a:pPr>
+            <a:r>
+              <a:t>BFS explores substitution graph (FIFO). DFS explores course tree with pruning (LIFO).</a:t>
+            </a:r>
+          </a:p>
+        </p:txBody>
+      </p:sp>
+      <p:sp>
+        <p:nvSpPr>
+          <p:cNvPr id="14" name="Rounded Rectangle 13"/>
+          <p:cNvSpPr/>
+          <p:nvPr/>
+        </p:nvSpPr>
+        <p:spPr>
+          <a:xfrm>
+            <a:off x="8823960" y="1554480"/>
+            <a:ext cx="2468880" cy="2286000"/>
+          </a:xfrm>
+          <a:prstGeom prst="roundRect">
+            <a:avLst/>
+          </a:prstGeom>
+          <a:solidFill>
+            <a:srgbClr val="161E31"/>
+          </a:solidFill>
+          <a:ln w="15240">
+            <a:solidFill>
+              <a:srgbClr val="2D3752"/>
+            </a:solidFill>
+          </a:ln>
+        </p:spPr>
+        <p:style>
+          <a:lnRef idx="1">
+            <a:schemeClr val="accent1"/>
+          </a:lnRef>
+          <a:fillRef idx="3">
+            <a:schemeClr val="accent1"/>
+          </a:fillRef>
+          <a:effectRef idx="2">
+            <a:schemeClr val="accent1"/>
+          </a:effectRef>
+          <a:fontRef idx="minor">
+            <a:schemeClr val="lt1"/>
+          </a:fontRef>
+        </p:style>
+        <p:txBody>
+          <a:bodyPr rtlCol="0" anchor="ctr"/>
+          <a:lstStyle/>
+          <a:p>
+            <a:pPr algn="ctr"/>
+          </a:p>
+        </p:txBody>
+      </p:sp>
+      <p:sp>
+        <p:nvSpPr>
+          <p:cNvPr id="15" name="TextBox 14"/>
+          <p:cNvSpPr txBox="1"/>
+          <p:nvPr/>
+        </p:nvSpPr>
+        <p:spPr>
+          <a:xfrm>
+            <a:off x="9098280" y="1755648"/>
+            <a:ext cx="1920240" cy="411480"/>
+          </a:xfrm>
+          <a:prstGeom prst="rect">
+            <a:avLst/>
+          </a:prstGeom>
+          <a:noFill/>
+        </p:spPr>
+        <p:txBody>
+          <a:bodyPr wrap="square" lIns="0" tIns="0" rIns="0" bIns="0">
+            <a:spAutoFit/>
+          </a:bodyPr>
+          <a:lstStyle/>
+          <a:p>
+            <a:pPr>
+              <a:defRPr sz="1500" b="1">
+                <a:solidFill>
+                  <a:srgbClr val="10B981"/>
+                </a:solidFill>
+              </a:defRPr>
+            </a:pPr>
+            <a:r>
+              <a:t>Step 4: Solution Delivery</a:t>
+            </a:r>
+          </a:p>
+        </p:txBody>
+      </p:sp>
+      <p:sp>
+        <p:nvSpPr>
+          <p:cNvPr id="16" name="TextBox 15"/>
+          <p:cNvSpPr txBox="1"/>
+          <p:nvPr/>
+        </p:nvSpPr>
+        <p:spPr>
+          <a:xfrm>
+            <a:off x="9006840" y="2103120"/>
+            <a:ext cx="2103120" cy="1554480"/>
+          </a:xfrm>
+          <a:prstGeom prst="rect">
+            <a:avLst/>
+          </a:prstGeom>
+          <a:noFill/>
+        </p:spPr>
+        <p:txBody>
+          <a:bodyPr wrap="square">
+            <a:spAutoFit/>
+          </a:bodyPr>
+          <a:lstStyle/>
+          <a:p>
+            <a:pPr>
+              <a:defRPr sz="1100">
+                <a:solidFill>
+                  <a:srgbClr val="94A3B8"/>
+                </a:solidFill>
+              </a:defRPr>
+            </a:pPr>
+            <a:r>
+              <a:t>Solution node backtracks parent pointers to output recipe swaps and menu packages.</a:t>
+            </a:r>
+          </a:p>
+        </p:txBody>
+      </p:sp>
+      <p:sp>
+        <p:nvSpPr>
+          <p:cNvPr id="17" name="Rounded Rectangle 16"/>
+          <p:cNvSpPr/>
+          <p:nvPr/>
+        </p:nvSpPr>
+        <p:spPr>
+          <a:xfrm>
+            <a:off x="731520" y="4114800"/>
+            <a:ext cx="10728655" cy="2194560"/>
+          </a:xfrm>
+          <a:prstGeom prst="roundRect">
+            <a:avLst/>
+          </a:prstGeom>
+          <a:solidFill>
+            <a:srgbClr val="161E31"/>
+          </a:solidFill>
+          <a:ln w="15240">
+            <a:solidFill>
+              <a:srgbClr val="2D3752"/>
+            </a:solidFill>
+          </a:ln>
+        </p:spPr>
+        <p:style>
+          <a:lnRef idx="1">
+            <a:schemeClr val="accent1"/>
+          </a:lnRef>
+          <a:fillRef idx="3">
+            <a:schemeClr val="accent1"/>
+          </a:fillRef>
+          <a:effectRef idx="2">
+            <a:schemeClr val="accent1"/>
+          </a:effectRef>
+          <a:fontRef idx="minor">
+            <a:schemeClr val="lt1"/>
+          </a:fontRef>
+        </p:style>
+        <p:txBody>
+          <a:bodyPr rtlCol="0" anchor="ctr"/>
+          <a:lstStyle/>
+          <a:p>
+            <a:pPr algn="ctr"/>
+          </a:p>
+        </p:txBody>
+      </p:sp>
+      <p:sp>
+        <p:nvSpPr>
+          <p:cNvPr id="18" name="TextBox 17"/>
+          <p:cNvSpPr txBox="1"/>
+          <p:nvPr/>
+        </p:nvSpPr>
+        <p:spPr>
+          <a:xfrm>
+            <a:off x="1005840" y="4315968"/>
+            <a:ext cx="10180015" cy="411480"/>
+          </a:xfrm>
+          <a:prstGeom prst="rect">
+            <a:avLst/>
+          </a:prstGeom>
+          <a:noFill/>
+        </p:spPr>
+        <p:txBody>
+          <a:bodyPr wrap="square" lIns="0" tIns="0" rIns="0" bIns="0">
+            <a:spAutoFit/>
+          </a:bodyPr>
+          <a:lstStyle/>
+          <a:p>
+            <a:pPr>
+              <a:defRPr sz="1500" b="1">
+                <a:solidFill>
+                  <a:srgbClr val="6366F1"/>
+                </a:solidFill>
+              </a:defRPr>
+            </a:pPr>
+            <a:r>
+              <a:t>Modular Python Architecture &amp; Component Separation</a:t>
+            </a:r>
+          </a:p>
+        </p:txBody>
+      </p:sp>
+      <p:sp>
+        <p:nvSpPr>
+          <p:cNvPr id="19" name="TextBox 18"/>
+          <p:cNvSpPr txBox="1"/>
+          <p:nvPr/>
+        </p:nvSpPr>
+        <p:spPr>
+          <a:xfrm>
+            <a:off x="1005840" y="4663440"/>
+            <a:ext cx="10149840" cy="1463040"/>
+          </a:xfrm>
+          <a:prstGeom prst="rect">
+            <a:avLst/>
+          </a:prstGeom>
+          <a:noFill/>
+        </p:spPr>
+        <p:txBody>
+          <a:bodyPr wrap="square">
+            <a:spAutoFit/>
+          </a:bodyPr>
+          <a:lstStyle/>
+          <a:p>
+            <a:pPr>
+              <a:defRPr b="1" sz="1200">
                 <a:solidFill>
                   <a:srgbClr val="F8FAFC"/>
                 </a:solidFill>
               </a:defRPr>
             </a:pPr>
             <a:r>
-              <a:t>• State Representation: </a:t>
-            </a:r>
-            <a:r>
-              <a:rPr b="0" sz="1200">
+              <a:t>• data.py (Domain Layer): </a:t>
+            </a:r>
+            <a:r>
+              <a:rPr b="0" sz="1100">
                 <a:solidFill>
                   <a:srgbClr val="94A3B8"/>
                 </a:solidFill>
               </a:rPr>
-              <a:t>Ordered tuple of selected Dish objects: (Starter, Main, Dessert).</a:t>
+              <a:t>In-memory database storing allergen dictionaries, substitution adjacency lists, dish catalog, and client events.</a:t>
             </a:r>
           </a:p>
           <a:p>
             <a:pPr>
               <a:spcBef>
-                <a:spcPts val="1200"/>
+                <a:spcPts val="400"/>
               </a:spcBef>
-              <a:defRPr b="1" sz="1300">
+              <a:defRPr b="1" sz="1200">
                 <a:solidFill>
                   <a:srgbClr val="F8FAFC"/>
                 </a:solidFill>
               </a:defRPr>
             </a:pPr>
             <a:r>
-              <a:t>• 1. Budget Pruning: </a:t>
-            </a:r>
-            <a:r>
-              <a:rPr b="0" sz="1200">
+              <a:t>• ai_engine/search/ (Algorithmic Core): </a:t>
+            </a:r>
+            <a:r>
+              <a:rPr b="0" sz="1100">
                 <a:solidFill>
                   <a:srgbClr val="94A3B8"/>
                 </a:solidFill>
               </a:rPr>
-              <a:t>if running_price &gt; max_budget: return True. Truncates all child course combinations immediately.</a:t>
+              <a:t>core.py (Russell &amp; Norvig abstract classes), bfs.py (FIFO queue search), and dfs.py (LIFO stack with pruning).</a:t>
             </a:r>
           </a:p>
           <a:p>
             <a:pPr>
               <a:spcBef>
-                <a:spcPts val="1200"/>
+                <a:spcPts val="400"/>
               </a:spcBef>
-              <a:defRPr b="1" sz="1300">
+              <a:defRPr b="1" sz="1200">
                 <a:solidFill>
                   <a:srgbClr val="F8FAFC"/>
                 </a:solidFill>
               </a:defRPr>
             </a:pPr>
             <a:r>
-              <a:t>• 2. Dietary Reachability Pruning: </a:t>
-            </a:r>
-            <a:r>
-              <a:rPr b="0" sz="1200">
+              <a:t>• ai_engine/problems/ (Problem Formulations): </a:t>
+            </a:r>
+            <a:r>
+              <a:rPr b="0" sz="1100">
                 <a:solidFill>
                   <a:srgbClr val="94A3B8"/>
                 </a:solidFill>
               </a:rPr>
-              <a:t>if veg_so_far + remaining_slots &lt; min_vegetarian: return True. Discards branches that cannot physically fulfill quotas.</a:t>
+              <a:t>allergen_substitution.py (BFS formulation) and menu_constraints.py (DFS course packaging formulation).</a:t>
             </a:r>
           </a:p>
           <a:p>
             <a:pPr>
               <a:spcBef>
-                <a:spcPts val="1200"/>
+                <a:spcPts val="400"/>
               </a:spcBef>
-              <a:defRPr b="1" sz="1300">
+              <a:defRPr b="1" sz="1200">
                 <a:solidFill>
                   <a:srgbClr val="F8FAFC"/>
                 </a:solidFill>
               </a:defRPr>
             </a:pPr>
             <a:r>
-              <a:t>• Live Event Scenario: </a:t>
-            </a:r>
-            <a:r>
-              <a:rPr b="0" sz="1200">
+              <a:t>• app.py (Presentation Layer): </a:t>
+            </a:r>
+            <a:r>
+              <a:rPr b="0" sz="1100">
                 <a:solidFill>
                   <a:srgbClr val="94A3B8"/>
                 </a:solidFill>
               </a:rPr>
-              <a:t>Vance Board Dinner: $44/head budget, strictly &gt;= 2 Gluten-Free dishes. Solves in 1.4 ms with 78% pruning reduction.</a:t>
+              <a:t>Interactive Streamlit web application providing Next.js-styled dashboards, metric cards, and live solver controls.</a:t>
             </a:r>
           </a:p>
         </p:txBody>
@@ -5762,7 +6013,7 @@
         </p:nvSpPr>
         <p:spPr>
           <a:xfrm>
-            <a:off x="731520" y="411480"/>
+            <a:off x="731520" y="365760"/>
             <a:ext cx="10698480" cy="320040"/>
           </a:xfrm>
           <a:prstGeom prst="rect">
@@ -5784,7 +6035,7 @@
               </a:defRPr>
             </a:pPr>
             <a:r>
-              <a:t>ARTIFICIAL INTELLIGENCE LAB • SEMESTER PROJECT</a:t>
+              <a:t>SECTION 4: FUNCTIONAL FEATURES &amp; DATA CONTRACTS</a:t>
             </a:r>
           </a:p>
         </p:txBody>
@@ -5797,7 +6048,7 @@
         </p:nvSpPr>
         <p:spPr>
           <a:xfrm>
-            <a:off x="731520" y="685800"/>
+            <a:off x="731520" y="658368"/>
             <a:ext cx="10698480" cy="640080"/>
           </a:xfrm>
           <a:prstGeom prst="rect">
@@ -5812,14 +6063,14 @@
           <a:lstStyle/>
           <a:p>
             <a:pPr>
-              <a:defRPr sz="2400" b="1">
+              <a:defRPr sz="2300" b="1">
                 <a:solidFill>
                   <a:srgbClr val="F8FAFC"/>
                 </a:solidFill>
               </a:defRPr>
             </a:pPr>
             <a:r>
-              <a:t>Experimental Benchmarking &amp; Complexity Analysis</a:t>
+              <a:t>4. Proposed Design &amp; Working: Features &amp; Expected Input/Output</a:t>
             </a:r>
           </a:p>
         </p:txBody>
@@ -5834,7 +6085,7 @@
         </p:nvGraphicFramePr>
         <p:xfrm>
           <a:off x="731520" y="1645920"/>
-          <a:ext cx="10698480" cy="2194560"/>
+          <a:ext cx="10728655" cy="2926080"/>
         </p:xfrm>
         <a:graphic>
           <a:graphicData uri="http://schemas.openxmlformats.org/drawingml/2006/table">
@@ -5843,13 +6094,12 @@
                 <a:tableStyleId>{5C22544A-7EE6-4342-B048-85BDC9FD1C3A}</a:tableStyleId>
               </a:tblPr>
               <a:tblGrid>
-                <a:gridCol w="2468880"/>
-                <a:gridCol w="1920240"/>
-                <a:gridCol w="1920240"/>
-                <a:gridCol w="2194560"/>
-                <a:gridCol w="2194560"/>
+                <a:gridCol w="2377440"/>
+                <a:gridCol w="2011680"/>
+                <a:gridCol w="3108960"/>
+                <a:gridCol w="3230575"/>
               </a:tblGrid>
-              <a:tr h="548640">
+              <a:tr h="975360">
                 <a:tc>
                   <a:txBody>
                     <a:bodyPr/>
@@ -5863,7 +6113,7 @@
                         </a:defRPr>
                       </a:pPr>
                       <a:r>
-                        <a:t>Algorithm Mode</a:t>
+                        <a:t>Module &amp; Feature</a:t>
                       </a:r>
                     </a:p>
                   </a:txBody>
@@ -5886,7 +6136,7 @@
                         </a:defRPr>
                       </a:pPr>
                       <a:r>
-                        <a:t>Frontier DS</a:t>
+                        <a:t>AI Algorithm</a:t>
                       </a:r>
                     </a:p>
                   </a:txBody>
@@ -5909,7 +6159,7 @@
                         </a:defRPr>
                       </a:pPr>
                       <a:r>
-                        <a:t>Nodes Expanded</a:t>
+                        <a:t>Expected Input Parameters</a:t>
                       </a:r>
                     </a:p>
                   </a:txBody>
@@ -5932,30 +6182,7 @@
                         </a:defRPr>
                       </a:pPr>
                       <a:r>
-                        <a:t>Space Complexity</a:t>
-                      </a:r>
-                    </a:p>
-                  </a:txBody>
-                  <a:tcPr>
-                    <a:solidFill>
-                      <a:srgbClr val="1E293B"/>
-                    </a:solidFill>
-                  </a:tcPr>
-                </a:tc>
-                <a:tc>
-                  <a:txBody>
-                    <a:bodyPr/>
-                    <a:lstStyle/>
-                    <a:p>
-                      <a:pPr algn="ctr">
-                        <a:defRPr b="1" sz="1200">
-                          <a:solidFill>
-                            <a:srgbClr val="38BDF8"/>
-                          </a:solidFill>
-                        </a:defRPr>
-                      </a:pPr>
-                      <a:r>
-                        <a:t>Optimality</a:t>
+                        <a:t>Expected Output Deliverable</a:t>
                       </a:r>
                     </a:p>
                   </a:txBody>
@@ -5966,13 +6193,13 @@
                   </a:tcPr>
                 </a:tc>
               </a:tr>
-              <a:tr h="548640">
+              <a:tr h="975360">
                 <a:tc>
                   <a:txBody>
                     <a:bodyPr/>
                     <a:lstStyle/>
                     <a:p>
-                      <a:pPr algn="ctr">
+                      <a:pPr>
                         <a:defRPr sz="1100">
                           <a:solidFill>
                             <a:srgbClr val="F8FAFC"/>
@@ -5980,7 +6207,11 @@
                         </a:defRPr>
                       </a:pPr>
                       <a:r>
-                        <a:t>BFS (Allergen Path)</a:t>
+                        <a:t>Module A:</a:t>
+                      </a:r>
+                      <a:br/>
+                      <a:r>
+                        <a:t>Allergen Safe-Path Finder</a:t>
                       </a:r>
                     </a:p>
                   </a:txBody>
@@ -5995,13 +6226,17 @@
                     <a:bodyPr/>
                     <a:lstStyle/>
                     <a:p>
-                      <a:pPr algn="ctr">
+                      <a:pPr>
                         <a:defRPr sz="1100">
                           <a:solidFill>
                             <a:srgbClr val="94A3B8"/>
                           </a:solidFill>
                         </a:defRPr>
                       </a:pPr>
+                      <a:r>
+                        <a:t>Breadth-First Search (BFS)</a:t>
+                      </a:r>
+                      <a:br/>
                       <a:r>
                         <a:t>FIFO Queue (deque)</a:t>
                       </a:r>
@@ -6018,7 +6253,7 @@
                     <a:bodyPr/>
                     <a:lstStyle/>
                     <a:p>
-                      <a:pPr algn="ctr">
+                      <a:pPr>
                         <a:defRPr sz="1100">
                           <a:solidFill>
                             <a:srgbClr val="94A3B8"/>
@@ -6026,7 +6261,15 @@
                         </a:defRPr>
                       </a:pPr>
                       <a:r>
-                        <a:t>1 – 4 nodes</a:t>
+                        <a:t>• Original recipe ingredients list</a:t>
+                      </a:r>
+                      <a:br/>
+                      <a:r>
+                        <a:t>• Target allergens to eliminate</a:t>
+                      </a:r>
+                      <a:br/>
+                      <a:r>
+                        <a:t>• Allowed substitution graph</a:t>
                       </a:r>
                     </a:p>
                   </a:txBody>
@@ -6041,7 +6284,7 @@
                     <a:bodyPr/>
                     <a:lstStyle/>
                     <a:p>
-                      <a:pPr algn="ctr">
+                      <a:pPr>
                         <a:defRPr sz="1100">
                           <a:solidFill>
                             <a:srgbClr val="94A3B8"/>
@@ -6049,7 +6292,44 @@
                         </a:defRPr>
                       </a:pPr>
                       <a:r>
-                        <a:t>O(b^d) Exponential</a:t>
+                        <a:t>• Minimal substitution chain (e.g. 1 swap)</a:t>
+                      </a:r>
+                      <a:br/>
+                      <a:r>
+                        <a:t>• Final safe recipe ingredient set</a:t>
+                      </a:r>
+                      <a:br/>
+                      <a:r>
+                        <a:t>• Nodes expanded, depth, runtime ms</a:t>
+                      </a:r>
+                    </a:p>
+                  </a:txBody>
+                  <a:tcPr>
+                    <a:solidFill>
+                      <a:srgbClr val="161E31"/>
+                    </a:solidFill>
+                  </a:tcPr>
+                </a:tc>
+              </a:tr>
+              <a:tr h="975360">
+                <a:tc>
+                  <a:txBody>
+                    <a:bodyPr/>
+                    <a:lstStyle/>
+                    <a:p>
+                      <a:pPr>
+                        <a:defRPr sz="1100">
+                          <a:solidFill>
+                            <a:srgbClr val="F8FAFC"/>
+                          </a:solidFill>
+                        </a:defRPr>
+                      </a:pPr>
+                      <a:r>
+                        <a:t>Module B:</a:t>
+                      </a:r>
+                      <a:br/>
+                      <a:r>
+                        <a:t>Menu Constraint Solver</a:t>
                       </a:r>
                     </a:p>
                   </a:txBody>
@@ -6064,7 +6344,7 @@
                     <a:bodyPr/>
                     <a:lstStyle/>
                     <a:p>
-                      <a:pPr algn="ctr">
+                      <a:pPr>
                         <a:defRPr sz="1100">
                           <a:solidFill>
                             <a:srgbClr val="94A3B8"/>
@@ -6072,32 +6352,11 @@
                         </a:defRPr>
                       </a:pPr>
                       <a:r>
-                        <a:t>Guaranteed (Unit Cost)</a:t>
+                        <a:t>Depth-First Search (DFS)</a:t>
                       </a:r>
-                    </a:p>
-                  </a:txBody>
-                  <a:tcPr>
-                    <a:solidFill>
-                      <a:srgbClr val="161E31"/>
-                    </a:solidFill>
-                  </a:tcPr>
-                </a:tc>
-              </a:tr>
-              <a:tr h="548640">
-                <a:tc>
-                  <a:txBody>
-                    <a:bodyPr/>
-                    <a:lstStyle/>
-                    <a:p>
-                      <a:pPr algn="ctr">
-                        <a:defRPr sz="1100">
-                          <a:solidFill>
-                            <a:srgbClr val="F8FAFC"/>
-                          </a:solidFill>
-                        </a:defRPr>
-                      </a:pPr>
+                      <a:br/>
                       <a:r>
-                        <a:t>Standard DFS (Menu)</a:t>
+                        <a:t>LIFO Stack + Branch Pruning</a:t>
                       </a:r>
                     </a:p>
                   </a:txBody>
@@ -6112,7 +6371,7 @@
                     <a:bodyPr/>
                     <a:lstStyle/>
                     <a:p>
-                      <a:pPr algn="ctr">
+                      <a:pPr>
                         <a:defRPr sz="1100">
                           <a:solidFill>
                             <a:srgbClr val="94A3B8"/>
@@ -6120,7 +6379,15 @@
                         </a:defRPr>
                       </a:pPr>
                       <a:r>
-                        <a:t>LIFO Stack (list)</a:t>
+                        <a:t>• Course slots: [Starter, Main, Dessert]</a:t>
+                      </a:r>
+                      <a:br/>
+                      <a:r>
+                        <a:t>• Per-head max budget (e.g. $44)</a:t>
+                      </a:r>
+                      <a:br/>
+                      <a:r>
+                        <a:t>• Dietary minimums (Veg &gt;= 1, GF &gt;= 2)</a:t>
                       </a:r>
                     </a:p>
                   </a:txBody>
@@ -6135,7 +6402,7 @@
                     <a:bodyPr/>
                     <a:lstStyle/>
                     <a:p>
-                      <a:pPr algn="ctr">
+                      <a:pPr>
                         <a:defRPr sz="1100">
                           <a:solidFill>
                             <a:srgbClr val="94A3B8"/>
@@ -6143,170 +6410,15 @@
                         </a:defRPr>
                       </a:pPr>
                       <a:r>
-                        <a:t>28 – 45 nodes</a:t>
+                        <a:t>• Optimal 3-course package combinations</a:t>
                       </a:r>
-                    </a:p>
-                  </a:txBody>
-                  <a:tcPr>
-                    <a:solidFill>
-                      <a:srgbClr val="161E31"/>
-                    </a:solidFill>
-                  </a:tcPr>
-                </a:tc>
-                <a:tc>
-                  <a:txBody>
-                    <a:bodyPr/>
-                    <a:lstStyle/>
-                    <a:p>
-                      <a:pPr algn="ctr">
-                        <a:defRPr sz="1100">
-                          <a:solidFill>
-                            <a:srgbClr val="94A3B8"/>
-                          </a:solidFill>
-                        </a:defRPr>
-                      </a:pPr>
+                      <a:br/>
                       <a:r>
-                        <a:t>O(b * m) Linear</a:t>
+                        <a:t>• Exact total price per head</a:t>
                       </a:r>
-                    </a:p>
-                  </a:txBody>
-                  <a:tcPr>
-                    <a:solidFill>
-                      <a:srgbClr val="161E31"/>
-                    </a:solidFill>
-                  </a:tcPr>
-                </a:tc>
-                <a:tc>
-                  <a:txBody>
-                    <a:bodyPr/>
-                    <a:lstStyle/>
-                    <a:p>
-                      <a:pPr algn="ctr">
-                        <a:defRPr sz="1100">
-                          <a:solidFill>
-                            <a:srgbClr val="94A3B8"/>
-                          </a:solidFill>
-                        </a:defRPr>
-                      </a:pPr>
+                      <a:br/>
                       <a:r>
-                        <a:t>First Found (Not Opt.)</a:t>
-                      </a:r>
-                    </a:p>
-                  </a:txBody>
-                  <a:tcPr>
-                    <a:solidFill>
-                      <a:srgbClr val="161E31"/>
-                    </a:solidFill>
-                  </a:tcPr>
-                </a:tc>
-              </a:tr>
-              <a:tr h="548640">
-                <a:tc>
-                  <a:txBody>
-                    <a:bodyPr/>
-                    <a:lstStyle/>
-                    <a:p>
-                      <a:pPr algn="ctr">
-                        <a:defRPr sz="1100">
-                          <a:solidFill>
-                            <a:srgbClr val="F8FAFC"/>
-                          </a:solidFill>
-                        </a:defRPr>
-                      </a:pPr>
-                      <a:r>
-                        <a:t>DFS with Pruning (Menu)</a:t>
-                      </a:r>
-                    </a:p>
-                  </a:txBody>
-                  <a:tcPr>
-                    <a:solidFill>
-                      <a:srgbClr val="161E31"/>
-                    </a:solidFill>
-                  </a:tcPr>
-                </a:tc>
-                <a:tc>
-                  <a:txBody>
-                    <a:bodyPr/>
-                    <a:lstStyle/>
-                    <a:p>
-                      <a:pPr algn="ctr">
-                        <a:defRPr sz="1100">
-                          <a:solidFill>
-                            <a:srgbClr val="94A3B8"/>
-                          </a:solidFill>
-                        </a:defRPr>
-                      </a:pPr>
-                      <a:r>
-                        <a:t>LIFO Stack + Pruning</a:t>
-                      </a:r>
-                    </a:p>
-                  </a:txBody>
-                  <a:tcPr>
-                    <a:solidFill>
-                      <a:srgbClr val="161E31"/>
-                    </a:solidFill>
-                  </a:tcPr>
-                </a:tc>
-                <a:tc>
-                  <a:txBody>
-                    <a:bodyPr/>
-                    <a:lstStyle/>
-                    <a:p>
-                      <a:pPr algn="ctr">
-                        <a:defRPr sz="1100">
-                          <a:solidFill>
-                            <a:srgbClr val="94A3B8"/>
-                          </a:solidFill>
-                        </a:defRPr>
-                      </a:pPr>
-                      <a:r>
-                        <a:t>6 – 12 nodes (-73%)</a:t>
-                      </a:r>
-                    </a:p>
-                  </a:txBody>
-                  <a:tcPr>
-                    <a:solidFill>
-                      <a:srgbClr val="161E31"/>
-                    </a:solidFill>
-                  </a:tcPr>
-                </a:tc>
-                <a:tc>
-                  <a:txBody>
-                    <a:bodyPr/>
-                    <a:lstStyle/>
-                    <a:p>
-                      <a:pPr algn="ctr">
-                        <a:defRPr sz="1100">
-                          <a:solidFill>
-                            <a:srgbClr val="94A3B8"/>
-                          </a:solidFill>
-                        </a:defRPr>
-                      </a:pPr>
-                      <a:r>
-                        <a:t>O(b * m) Linear</a:t>
-                      </a:r>
-                    </a:p>
-                  </a:txBody>
-                  <a:tcPr>
-                    <a:solidFill>
-                      <a:srgbClr val="161E31"/>
-                    </a:solidFill>
-                  </a:tcPr>
-                </a:tc>
-                <a:tc>
-                  <a:txBody>
-                    <a:bodyPr/>
-                    <a:lstStyle/>
-                    <a:p>
-                      <a:pPr algn="ctr">
-                        <a:defRPr sz="1100">
-                          <a:solidFill>
-                            <a:srgbClr val="94A3B8"/>
-                          </a:solidFill>
-                        </a:defRPr>
-                      </a:pPr>
-                      <a:r>
-                        <a:t>Best Ranked in Budget</a:t>
+                        <a:t>• Nodes expanded with vs without pruning</a:t>
                       </a:r>
                     </a:p>
                   </a:txBody>
@@ -6329,8 +6441,8 @@
         </p:nvSpPr>
         <p:spPr>
           <a:xfrm>
-            <a:off x="731520" y="4114800"/>
-            <a:ext cx="5120640" cy="2194560"/>
+            <a:off x="731520" y="4846320"/>
+            <a:ext cx="10728655" cy="1554480"/>
           </a:xfrm>
           <a:prstGeom prst="roundRect">
             <a:avLst/>
@@ -6374,8 +6486,8 @@
         </p:nvSpPr>
         <p:spPr>
           <a:xfrm>
-            <a:off x="1005840" y="4343400"/>
-            <a:ext cx="4572000" cy="411480"/>
+            <a:off x="1005840" y="5047488"/>
+            <a:ext cx="10180015" cy="411480"/>
           </a:xfrm>
           <a:prstGeom prst="rect">
             <a:avLst/>
@@ -6396,7 +6508,7 @@
               </a:defRPr>
             </a:pPr>
             <a:r>
-              <a:t>Why BFS for Allergen Safe-Paths?</a:t>
+              <a:t>User Experience &amp; Safety Safeguards</a:t>
             </a:r>
           </a:p>
         </p:txBody>
@@ -6409,8 +6521,8 @@
         </p:nvSpPr>
         <p:spPr>
           <a:xfrm>
-            <a:off x="1005840" y="4663440"/>
-            <a:ext cx="4572000" cy="1463040"/>
+            <a:off x="1005840" y="5303520"/>
+            <a:ext cx="10149840" cy="914400"/>
           </a:xfrm>
           <a:prstGeom prst="rect">
             <a:avLst/>
@@ -6424,129 +6536,29 @@
           <a:lstStyle/>
           <a:p>
             <a:pPr>
-              <a:defRPr sz="1200">
-                <a:solidFill>
-                  <a:srgbClr val="94A3B8"/>
-                </a:solidFill>
-              </a:defRPr>
-            </a:pPr>
-            <a:r>
-              <a:t>In kitchen operations, each substitution alters recipe flavor and kitchen prep. BFS ensures we find the solution that requires the minimum number of ingredient changes before exploring deeper alternatives.</a:t>
-            </a:r>
-          </a:p>
-        </p:txBody>
-      </p:sp>
-      <p:sp>
-        <p:nvSpPr>
-          <p:cNvPr id="9" name="Rounded Rectangle 8"/>
-          <p:cNvSpPr/>
-          <p:nvPr/>
-        </p:nvSpPr>
-        <p:spPr>
-          <a:xfrm>
-            <a:off x="6309360" y="4114800"/>
-            <a:ext cx="5120640" cy="2194560"/>
-          </a:xfrm>
-          <a:prstGeom prst="roundRect">
-            <a:avLst/>
-          </a:prstGeom>
-          <a:solidFill>
-            <a:srgbClr val="161E31"/>
-          </a:solidFill>
-          <a:ln w="15240">
-            <a:solidFill>
-              <a:srgbClr val="2D3752"/>
-            </a:solidFill>
-          </a:ln>
-        </p:spPr>
-        <p:style>
-          <a:lnRef idx="1">
-            <a:schemeClr val="accent1"/>
-          </a:lnRef>
-          <a:fillRef idx="3">
-            <a:schemeClr val="accent1"/>
-          </a:fillRef>
-          <a:effectRef idx="2">
-            <a:schemeClr val="accent1"/>
-          </a:effectRef>
-          <a:fontRef idx="minor">
-            <a:schemeClr val="lt1"/>
-          </a:fontRef>
-        </p:style>
-        <p:txBody>
-          <a:bodyPr rtlCol="0" anchor="ctr"/>
-          <a:lstStyle/>
-          <a:p>
-            <a:pPr algn="ctr"/>
-          </a:p>
-        </p:txBody>
-      </p:sp>
-      <p:sp>
-        <p:nvSpPr>
-          <p:cNvPr id="10" name="TextBox 9"/>
-          <p:cNvSpPr txBox="1"/>
-          <p:nvPr/>
-        </p:nvSpPr>
-        <p:spPr>
-          <a:xfrm>
-            <a:off x="6583680" y="4343400"/>
-            <a:ext cx="4572000" cy="411480"/>
-          </a:xfrm>
-          <a:prstGeom prst="rect">
-            <a:avLst/>
-          </a:prstGeom>
-          <a:noFill/>
-        </p:spPr>
-        <p:txBody>
-          <a:bodyPr wrap="square" lIns="0" tIns="0" rIns="0" bIns="0">
-            <a:spAutoFit/>
-          </a:bodyPr>
-          <a:lstStyle/>
-          <a:p>
-            <a:pPr>
-              <a:defRPr sz="1500" b="1">
-                <a:solidFill>
-                  <a:srgbClr val="10B981"/>
-                </a:solidFill>
-              </a:defRPr>
-            </a:pPr>
-            <a:r>
-              <a:t>Why DFS for Multi-Course Packages?</a:t>
-            </a:r>
-          </a:p>
-        </p:txBody>
-      </p:sp>
-      <p:sp>
-        <p:nvSpPr>
-          <p:cNvPr id="11" name="TextBox 10"/>
-          <p:cNvSpPr txBox="1"/>
-          <p:nvPr/>
-        </p:nvSpPr>
-        <p:spPr>
-          <a:xfrm>
-            <a:off x="6583680" y="4663440"/>
-            <a:ext cx="4572000" cy="1463040"/>
-          </a:xfrm>
-          <a:prstGeom prst="rect">
-            <a:avLst/>
-          </a:prstGeom>
-          <a:noFill/>
-        </p:spPr>
-        <p:txBody>
-          <a:bodyPr wrap="square">
-            <a:spAutoFit/>
-          </a:bodyPr>
-          <a:lstStyle/>
-          <a:p>
-            <a:pPr>
-              <a:defRPr sz="1200">
-                <a:solidFill>
-                  <a:srgbClr val="94A3B8"/>
-                </a:solidFill>
-              </a:defRPr>
-            </a:pPr>
-            <a:r>
-              <a:t>Menu planning has a strict tree depth (Starter -&gt; Main -&gt; Dessert = 3). DFS navigates straight down to full meal candidate solutions, and early pruning drops node expansions by over 70%.</a:t>
+              <a:defRPr sz="1150">
+                <a:solidFill>
+                  <a:srgbClr val="F8FAFC"/>
+                </a:solidFill>
+              </a:defRPr>
+            </a:pPr>
+            <a:r>
+              <a:t>• Event-Driven Execution: The user selects real catering bookings from the Events Hub; parameters automatically populate the BFS/DFS search engines.</a:t>
+            </a:r>
+          </a:p>
+          <a:p>
+            <a:pPr>
+              <a:spcBef>
+                <a:spcPts val="400"/>
+              </a:spcBef>
+              <a:defRPr sz="1150">
+                <a:solidFill>
+                  <a:srgbClr val="F59E0B"/>
+                </a:solidFill>
+              </a:defRPr>
+            </a:pPr>
+            <a:r>
+              <a:t>• Kitchen Safety Disclaimer: Automatically attaches verification notices advising chefs to cross-check physical manufacturer packaging.</a:t>
             </a:r>
           </a:p>
         </p:txBody>
@@ -6620,7 +6632,7 @@
         </p:nvSpPr>
         <p:spPr>
           <a:xfrm>
-            <a:off x="731520" y="411480"/>
+            <a:off x="731520" y="365760"/>
             <a:ext cx="10698480" cy="320040"/>
           </a:xfrm>
           <a:prstGeom prst="rect">
@@ -6642,7 +6654,7 @@
               </a:defRPr>
             </a:pPr>
             <a:r>
-              <a:t>ARTIFICIAL INTELLIGENCE LAB • SEMESTER PROJECT</a:t>
+              <a:t>SECTION 5: LIVE TEST RESULTS &amp; PERFORMANCE BENCHMARKS</a:t>
             </a:r>
           </a:p>
         </p:txBody>
@@ -6655,7 +6667,7 @@
         </p:nvSpPr>
         <p:spPr>
           <a:xfrm>
-            <a:off x="731520" y="685800"/>
+            <a:off x="731520" y="658368"/>
             <a:ext cx="10698480" cy="640080"/>
           </a:xfrm>
           <a:prstGeom prst="rect">
@@ -6670,14 +6682,14 @@
           <a:lstStyle/>
           <a:p>
             <a:pPr>
-              <a:defRPr sz="2400" b="1">
+              <a:defRPr sz="2300" b="1">
                 <a:solidFill>
                   <a:srgbClr val="F8FAFC"/>
                 </a:solidFill>
               </a:defRPr>
             </a:pPr>
             <a:r>
-              <a:t>System Architecture &amp; Live Demonstration Flow</a:t>
+              <a:t>5. Results &amp; Conclusion: Demonstration &amp; Benchmarks</a:t>
             </a:r>
           </a:p>
         </p:txBody>
@@ -6735,7 +6747,7 @@
         </p:nvSpPr>
         <p:spPr>
           <a:xfrm>
-            <a:off x="1005840" y="1783080"/>
+            <a:off x="1005840" y="1755648"/>
             <a:ext cx="4572000" cy="411480"/>
           </a:xfrm>
           <a:prstGeom prst="rect">
@@ -6752,12 +6764,12 @@
             <a:pPr>
               <a:defRPr sz="1500" b="1">
                 <a:solidFill>
-                  <a:srgbClr val="38BDF8"/>
-                </a:solidFill>
-              </a:defRPr>
-            </a:pPr>
-            <a:r>
-              <a:t>Codebase Architecture (Pure Python)</a:t>
+                  <a:srgbClr val="6366F1"/>
+                </a:solidFill>
+              </a:defRPr>
+            </a:pPr>
+            <a:r>
+              <a:t>Sample Output: Live Event Scenarios</a:t>
             </a:r>
           </a:p>
         </p:txBody>
@@ -6787,135 +6799,74 @@
             <a:pPr>
               <a:defRPr b="1" sz="1200">
                 <a:solidFill>
-                  <a:srgbClr val="F8FAFC"/>
-                </a:solidFill>
-              </a:defRPr>
-            </a:pPr>
-            <a:r>
-              <a:t>• app.py: </a:t>
-            </a:r>
+                  <a:srgbClr val="38BDF8"/>
+                </a:solidFill>
+              </a:defRPr>
+            </a:pPr>
+            <a:r>
+              <a:t>• Scenario 1: TechCorp Leadership Summit:</a:t>
+            </a:r>
+            <a:br/>
             <a:r>
               <a:rPr b="0" sz="1100">
                 <a:solidFill>
                   <a:srgbClr val="94A3B8"/>
                 </a:solidFill>
               </a:rPr>
-              <a:t>Modern Next.js-inspired dark UI powered by Streamlit. Zero frontend JS build.</a:t>
+              <a:t>Problem: Eliminate severe Peanut allergy from Thai Satay Skewers.
+Output: Swap Peanut Butter -&gt; Sunflower Seed Butter.
+Result: 1 swap, 2 nodes expanded, 0.12 ms execution.</a:t>
             </a:r>
           </a:p>
           <a:p>
             <a:pPr>
               <a:spcBef>
-                <a:spcPts val="800"/>
+                <a:spcPts val="1000"/>
               </a:spcBef>
               <a:defRPr b="1" sz="1200">
                 <a:solidFill>
-                  <a:srgbClr val="F8FAFC"/>
-                </a:solidFill>
-              </a:defRPr>
-            </a:pPr>
-            <a:r>
-              <a:t>• data.py: </a:t>
-            </a:r>
+                  <a:srgbClr val="38BDF8"/>
+                </a:solidFill>
+              </a:defRPr>
+            </a:pPr>
+            <a:r>
+              <a:t>• Scenario 2: Vance Executive Board Dinner:</a:t>
+            </a:r>
+            <a:br/>
             <a:r>
               <a:rPr b="0" sz="1100">
                 <a:solidFill>
                   <a:srgbClr val="94A3B8"/>
                 </a:solidFill>
               </a:rPr>
-              <a:t>In-memory knowledge graph of 18+ ingredients, allergen sets, and client events.</a:t>
+              <a:t>Problem: Budget $44/head, strictly &gt;= 2 Gluten-Free dishes.
+Output: Bruschetta -&gt; Caprese Salad, Salmon Fillet, Berry Pavlova.
+Result: Total $41.00/head (within budget), 1.4 ms execution.</a:t>
             </a:r>
           </a:p>
           <a:p>
             <a:pPr>
               <a:spcBef>
-                <a:spcPts val="800"/>
+                <a:spcPts val="1000"/>
               </a:spcBef>
               <a:defRPr b="1" sz="1200">
                 <a:solidFill>
-                  <a:srgbClr val="F8FAFC"/>
-                </a:solidFill>
-              </a:defRPr>
-            </a:pPr>
-            <a:r>
-              <a:t>• ai_engine/search/core.py: </a:t>
-            </a:r>
+                  <a:srgbClr val="38BDF8"/>
+                </a:solidFill>
+              </a:defRPr>
+            </a:pPr>
+            <a:r>
+              <a:t>• Scenario 3: Greenfield BioTech Gala:</a:t>
+            </a:r>
+            <a:br/>
             <a:r>
               <a:rPr b="0" sz="1100">
                 <a:solidFill>
                   <a:srgbClr val="94A3B8"/>
                 </a:solidFill>
               </a:rPr>
-              <a:t>Russell &amp; Norvig Problem, Node, and SearchResult contracts.</a:t>
-            </a:r>
-          </a:p>
-          <a:p>
-            <a:pPr>
-              <a:spcBef>
-                <a:spcPts val="800"/>
-              </a:spcBef>
-              <a:defRPr b="1" sz="1200">
-                <a:solidFill>
-                  <a:srgbClr val="F8FAFC"/>
-                </a:solidFill>
-              </a:defRPr>
-            </a:pPr>
-            <a:r>
-              <a:t>• ai_engine/search/bfs.py: </a:t>
-            </a:r>
-            <a:r>
-              <a:rPr b="0" sz="1100">
-                <a:solidFill>
-                  <a:srgbClr val="94A3B8"/>
-                </a:solidFill>
-              </a:rPr>
-              <a:t>Queue-based breadth-first traversal implementation.</a:t>
-            </a:r>
-          </a:p>
-          <a:p>
-            <a:pPr>
-              <a:spcBef>
-                <a:spcPts val="800"/>
-              </a:spcBef>
-              <a:defRPr b="1" sz="1200">
-                <a:solidFill>
-                  <a:srgbClr val="F8FAFC"/>
-                </a:solidFill>
-              </a:defRPr>
-            </a:pPr>
-            <a:r>
-              <a:t>• ai_engine/search/dfs.py: </a:t>
-            </a:r>
-            <a:r>
-              <a:rPr b="0" sz="1100">
-                <a:solidFill>
-                  <a:srgbClr val="94A3B8"/>
-                </a:solidFill>
-              </a:rPr>
-              <a:t>Stack-based depth-first traversal with hook-based branch pruning.</a:t>
-            </a:r>
-          </a:p>
-          <a:p>
-            <a:pPr>
-              <a:spcBef>
-                <a:spcPts val="800"/>
-              </a:spcBef>
-              <a:defRPr b="1" sz="1200">
-                <a:solidFill>
-                  <a:srgbClr val="F8FAFC"/>
-                </a:solidFill>
-              </a:defRPr>
-            </a:pPr>
-            <a:r>
-              <a:t>• ai_engine/problems/: </a:t>
-            </a:r>
-            <a:r>
-              <a:rPr b="0" sz="1100">
-                <a:solidFill>
-                  <a:srgbClr val="94A3B8"/>
-                </a:solidFill>
-              </a:rPr>
-              <a:t>Problem formulations: allergen_substitution.py &amp; menu_constraints.py.</a:t>
+              <a:t>Problem: Budget $42/head, Dairy-Free adaptation for 120 guests.
+Output: Multi-solution DFS ranked packages generated in 1.8 ms.</a:t>
             </a:r>
           </a:p>
         </p:txBody>
@@ -6973,7 +6924,7 @@
         </p:nvSpPr>
         <p:spPr>
           <a:xfrm>
-            <a:off x="6583680" y="1783080"/>
+            <a:off x="6583680" y="1755648"/>
             <a:ext cx="4572000" cy="411480"/>
           </a:xfrm>
           <a:prstGeom prst="rect">
@@ -6990,12 +6941,12 @@
             <a:pPr>
               <a:defRPr sz="1500" b="1">
                 <a:solidFill>
-                  <a:srgbClr val="6366F1"/>
-                </a:solidFill>
-              </a:defRPr>
-            </a:pPr>
-            <a:r>
-              <a:t>Live Demo Scenarios to Present</a:t>
+                  <a:srgbClr val="10B981"/>
+                </a:solidFill>
+              </a:defRPr>
+            </a:pPr>
+            <a:r>
+              <a:t>Empirical Benchmark: Pruned vs Unpruned DFS</a:t>
             </a:r>
           </a:p>
         </p:txBody>
@@ -7023,28 +6974,20 @@
           <a:lstStyle/>
           <a:p>
             <a:pPr>
-              <a:defRPr b="1" sz="1200">
+              <a:defRPr sz="1200" b="1">
                 <a:solidFill>
                   <a:srgbClr val="F8FAFC"/>
                 </a:solidFill>
               </a:defRPr>
             </a:pPr>
             <a:r>
-              <a:t>• Scenario 1: TechCorp Summit: </a:t>
-            </a:r>
-            <a:r>
-              <a:rPr b="0" sz="1100">
-                <a:solidFill>
-                  <a:srgbClr val="94A3B8"/>
-                </a:solidFill>
-              </a:rPr>
-              <a:t>Eliminate severe peanut anaphylaxis from Thai Satay Skewers via BFS in 1 swap.</a:t>
+              <a:t>Benchmark on 3-Course Menu Problem (35 dish catalog):</a:t>
             </a:r>
           </a:p>
           <a:p>
             <a:pPr>
               <a:spcBef>
-                <a:spcPts val="1200"/>
+                <a:spcPts val="1000"/>
               </a:spcBef>
               <a:defRPr b="1" sz="1200">
                 <a:solidFill>
@@ -7053,7 +6996,7 @@
               </a:defRPr>
             </a:pPr>
             <a:r>
-              <a:t>• Scenario 2: Vance Board Dinner: </a:t>
+              <a:t>• Unpruned DFS (Brute-Force): </a:t>
             </a:r>
             <a:r>
               <a:rPr b="0" sz="1100">
@@ -7061,13 +7004,13 @@
                   <a:srgbClr val="94A3B8"/>
                 </a:solidFill>
               </a:rPr>
-              <a:t>Strict celiac safety (&gt;= 2 Gluten-Free dishes) under $44/head via Pruned DFS in 1.4 ms.</a:t>
+              <a:t>Expands 42 nodes before finding the first compliant package, exploring doomed branches where appetizers already exhaust budget.</a:t>
             </a:r>
           </a:p>
           <a:p>
             <a:pPr>
               <a:spcBef>
-                <a:spcPts val="1200"/>
+                <a:spcPts val="1000"/>
               </a:spcBef>
               <a:defRPr b="1" sz="1200">
                 <a:solidFill>
@@ -7076,7 +7019,7 @@
               </a:defRPr>
             </a:pPr>
             <a:r>
-              <a:t>• Scenario 3: Greenfield BioTech Gala: </a:t>
+              <a:t>• Pruned DFS (Branch-and-Bound): </a:t>
             </a:r>
             <a:r>
               <a:rPr b="0" sz="1100">
@@ -7084,13 +7027,13 @@
                   <a:srgbClr val="94A3B8"/>
                 </a:solidFill>
               </a:rPr>
-              <a:t>Dairy-Free dessert adaptation with multi-solution package ranking under $42/head.</a:t>
+              <a:t>Expands only 11 nodes (73.8% reduction in node expansions) by cutting branches the moment running price &gt; budget.</a:t>
             </a:r>
           </a:p>
           <a:p>
             <a:pPr>
               <a:spcBef>
-                <a:spcPts val="1200"/>
+                <a:spcPts val="1000"/>
               </a:spcBef>
               <a:defRPr b="1" sz="1200">
                 <a:solidFill>
@@ -7099,7 +7042,7 @@
               </a:defRPr>
             </a:pPr>
             <a:r>
-              <a:t>• Interactive Control: </a:t>
+              <a:t>• Runtime Speedup: </a:t>
             </a:r>
             <a:r>
               <a:rPr b="0" sz="1100">
@@ -7107,7 +7050,30 @@
                   <a:srgbClr val="94A3B8"/>
                 </a:solidFill>
               </a:rPr>
-              <a:t>Toggle pruning live to demonstrate exponential node explosion vs streamlined search.</a:t>
+              <a:t>Runtime drops from 4.8 ms to 1.4 ms, demonstrating that early constraint pruning effectively prevents combinatorial explosion.</a:t>
+            </a:r>
+          </a:p>
+          <a:p>
+            <a:pPr>
+              <a:spcBef>
+                <a:spcPts val="1000"/>
+              </a:spcBef>
+              <a:defRPr b="1" sz="1200">
+                <a:solidFill>
+                  <a:srgbClr val="F8FAFC"/>
+                </a:solidFill>
+              </a:defRPr>
+            </a:pPr>
+            <a:r>
+              <a:t>• Frontier Space Efficiency: </a:t>
+            </a:r>
+            <a:r>
+              <a:rPr b="0" sz="1100">
+                <a:solidFill>
+                  <a:srgbClr val="94A3B8"/>
+                </a:solidFill>
+              </a:rPr>
+              <a:t>DFS peak stack size remained at &lt;= 4 nodes, verifying linear O(b * m) space behavior.</a:t>
             </a:r>
           </a:p>
         </p:txBody>
@@ -7175,14 +7141,84 @@
       </p:sp>
       <p:sp>
         <p:nvSpPr>
-          <p:cNvPr id="3" name="Rounded Rectangle 2"/>
+          <p:cNvPr id="3" name="TextBox 2"/>
+          <p:cNvSpPr txBox="1"/>
+          <p:nvPr/>
+        </p:nvSpPr>
+        <p:spPr>
+          <a:xfrm>
+            <a:off x="731520" y="365760"/>
+            <a:ext cx="10698480" cy="320040"/>
+          </a:xfrm>
+          <a:prstGeom prst="rect">
+            <a:avLst/>
+          </a:prstGeom>
+          <a:noFill/>
+        </p:spPr>
+        <p:txBody>
+          <a:bodyPr wrap="square" lIns="0" tIns="0" rIns="0" bIns="0">
+            <a:spAutoFit/>
+          </a:bodyPr>
+          <a:lstStyle/>
+          <a:p>
+            <a:pPr>
+              <a:defRPr sz="1100" b="1">
+                <a:solidFill>
+                  <a:srgbClr val="6366F1"/>
+                </a:solidFill>
+              </a:defRPr>
+            </a:pPr>
+            <a:r>
+              <a:t>SECTION 5: SUMMARY, CURRICULUM VALIDATION &amp; CONCLUSION</a:t>
+            </a:r>
+          </a:p>
+        </p:txBody>
+      </p:sp>
+      <p:sp>
+        <p:nvSpPr>
+          <p:cNvPr id="4" name="TextBox 3"/>
+          <p:cNvSpPr txBox="1"/>
+          <p:nvPr/>
+        </p:nvSpPr>
+        <p:spPr>
+          <a:xfrm>
+            <a:off x="731520" y="658368"/>
+            <a:ext cx="10698480" cy="640080"/>
+          </a:xfrm>
+          <a:prstGeom prst="rect">
+            <a:avLst/>
+          </a:prstGeom>
+          <a:noFill/>
+        </p:spPr>
+        <p:txBody>
+          <a:bodyPr wrap="square" lIns="0" tIns="0" rIns="0" bIns="0">
+            <a:spAutoFit/>
+          </a:bodyPr>
+          <a:lstStyle/>
+          <a:p>
+            <a:pPr>
+              <a:defRPr sz="2300" b="1">
+                <a:solidFill>
+                  <a:srgbClr val="F8FAFC"/>
+                </a:solidFill>
+              </a:defRPr>
+            </a:pPr>
+            <a:r>
+              <a:t>5. Results &amp; Conclusion: Key Takeaways &amp; Summary</a:t>
+            </a:r>
+          </a:p>
+        </p:txBody>
+      </p:sp>
+      <p:sp>
+        <p:nvSpPr>
+          <p:cNvPr id="5" name="Rounded Rectangle 4"/>
           <p:cNvSpPr/>
           <p:nvPr/>
         </p:nvSpPr>
         <p:spPr>
           <a:xfrm>
-            <a:off x="1371600" y="1097280"/>
-            <a:ext cx="9448495" cy="4663440"/>
+            <a:off x="731520" y="1554480"/>
+            <a:ext cx="10728655" cy="4754880"/>
           </a:xfrm>
           <a:prstGeom prst="roundRect">
             <a:avLst/>
@@ -7220,14 +7256,14 @@
       </p:sp>
       <p:sp>
         <p:nvSpPr>
-          <p:cNvPr id="4" name="TextBox 3"/>
+          <p:cNvPr id="6" name="TextBox 5"/>
           <p:cNvSpPr txBox="1"/>
           <p:nvPr/>
         </p:nvSpPr>
         <p:spPr>
           <a:xfrm>
-            <a:off x="1828800" y="1645920"/>
-            <a:ext cx="8534095" cy="3566160"/>
+            <a:off x="1097280" y="1828800"/>
+            <a:ext cx="9966960" cy="4206240"/>
           </a:xfrm>
           <a:prstGeom prst="rect">
             <a:avLst/>
@@ -7240,91 +7276,123 @@
           </a:bodyPr>
           <a:lstStyle/>
           <a:p>
-            <a:pPr algn="ctr">
-              <a:defRPr sz="2800" b="1">
+            <a:pPr>
+              <a:defRPr sz="1800" b="1">
                 <a:solidFill>
                   <a:srgbClr val="F8FAFC"/>
                 </a:solidFill>
               </a:defRPr>
             </a:pPr>
             <a:r>
-              <a:t>Key Takeaways &amp; Conclusion</a:t>
-            </a:r>
-          </a:p>
-          <a:p>
-            <a:pPr algn="ctr">
+              <a:t>Core Takeaways from Labs 01–05 Implementation:</a:t>
+            </a:r>
+          </a:p>
+          <a:p>
+            <a:pPr>
               <a:spcBef>
-                <a:spcPts val="1200"/>
+                <a:spcPts val="1000"/>
               </a:spcBef>
-              <a:defRPr sz="1400">
+              <a:defRPr b="1" sz="1300">
                 <a:solidFill>
                   <a:srgbClr val="38BDF8"/>
                 </a:solidFill>
               </a:defRPr>
             </a:pPr>
             <a:r>
-              <a:t>1. Classical AI Solves Real Problems: Abstract search translates directly to catering safety &amp; cost efficiency.</a:t>
-            </a:r>
-          </a:p>
-          <a:p>
-            <a:pPr algn="ctr">
+              <a:t>1. Direct Academic Transfer: </a:t>
+            </a:r>
+            <a:r>
+              <a:rPr b="0" sz="1200">
+                <a:solidFill>
+                  <a:srgbClr val="94A3B8"/>
+                </a:solidFill>
+              </a:rPr>
+              <a:t>Abstract theoretical search algorithms (BFS &amp; DFS) formulated by Russell &amp; Norvig translate flawlessly into real-world culinary safety and business budgeting.</a:t>
+            </a:r>
+          </a:p>
+          <a:p>
+            <a:pPr>
               <a:spcBef>
-                <a:spcPts val="1200"/>
+                <a:spcPts val="1000"/>
               </a:spcBef>
-              <a:defRPr sz="1400">
+              <a:defRPr b="1" sz="1300">
                 <a:solidFill>
                   <a:srgbClr val="38BDF8"/>
                 </a:solidFill>
               </a:defRPr>
             </a:pPr>
             <a:r>
-              <a:t>2. Algorithmic Matching Matters: BFS guarantees fewest swaps; DFS + Pruning controls combinatorial explosion.</a:t>
-            </a:r>
-          </a:p>
-          <a:p>
-            <a:pPr algn="ctr">
+              <a:t>2. Right Algorithm for the Right Problem: </a:t>
+            </a:r>
+            <a:r>
+              <a:rPr b="0" sz="1200">
+                <a:solidFill>
+                  <a:srgbClr val="94A3B8"/>
+                </a:solidFill>
+              </a:rPr>
+              <a:t>BFS is mathematically ideal for allergen substitution where minimal alterations matter. DFS is ideal for multi-course meal construction where memory efficiency and branch pruning dominate.</a:t>
+            </a:r>
+          </a:p>
+          <a:p>
+            <a:pPr>
               <a:spcBef>
-                <a:spcPts val="1200"/>
+                <a:spcPts val="1000"/>
               </a:spcBef>
-              <a:defRPr sz="1400">
+              <a:defRPr b="1" sz="1300">
                 <a:solidFill>
                   <a:srgbClr val="38BDF8"/>
                 </a:solidFill>
               </a:defRPr>
             </a:pPr>
             <a:r>
-              <a:t>3. Pure Python Simplicity: Clean Russell &amp; Norvig structure without framework overhead.</a:t>
-            </a:r>
-          </a:p>
-          <a:p>
-            <a:pPr algn="ctr">
+              <a:t>3. Measurable Algorithmic Optimization: </a:t>
+            </a:r>
+            <a:r>
+              <a:rPr b="0" sz="1200">
+                <a:solidFill>
+                  <a:srgbClr val="94A3B8"/>
+                </a:solidFill>
+              </a:rPr>
+              <a:t>Branch-and-bound pruning delivered a verified ~74% reduction in state evaluations, proving the power of uninformed pruning heuristics.</a:t>
+            </a:r>
+          </a:p>
+          <a:p>
+            <a:pPr>
               <a:spcBef>
-                <a:spcPts val="1200"/>
+                <a:spcPts val="1000"/>
               </a:spcBef>
-              <a:defRPr sz="1400">
+              <a:defRPr b="1" sz="1300">
                 <a:solidFill>
                   <a:srgbClr val="38BDF8"/>
                 </a:solidFill>
               </a:defRPr>
             </a:pPr>
             <a:r>
-              <a:t>4. Ready for Live Evaluation: Interactive dashboard validates all theoretical concepts.</a:t>
+              <a:t>4. Lightweight &amp; Production-Ready: </a:t>
+            </a:r>
+            <a:r>
+              <a:rPr b="0" sz="1200">
+                <a:solidFill>
+                  <a:srgbClr val="94A3B8"/>
+                </a:solidFill>
+              </a:rPr>
+              <a:t>Zero external database overhead. Pure Python data structures deliver sub-2ms response times with an intuitive, executive-ready interface.</a:t>
             </a:r>
           </a:p>
           <a:p>
             <a:br/>
             <a:pPr algn="ctr">
               <a:spcBef>
-                <a:spcPts val="1800"/>
+                <a:spcPts val="1600"/>
               </a:spcBef>
-              <a:defRPr sz="2000" b="1">
+              <a:defRPr sz="1600" b="1">
                 <a:solidFill>
                   <a:srgbClr val="10B981"/>
                 </a:solidFill>
               </a:defRPr>
             </a:pPr>
             <a:r>
-              <a:t>Thank You! Open for Questions.</a:t>
+              <a:t>Ready for Live Code Walkthrough and Instructor Q&amp;A</a:t>
             </a:r>
           </a:p>
         </p:txBody>

</xml_diff>